<commit_message>
Update DOCX and PPTX files for final qualifying work, including revisions to practice and defense reports, enhancements to figures and tables, and updates to Markdown content. Refactor report generation scripts to improve layout and formatting, ensuring compliance with project standards.
</commit_message>
<xml_diff>
--- a/build/pptx/practice-defense-draft.pptx
+++ b/build/pptx/practice-defense-draft.pptx
@@ -13,6 +13,7 @@
     <p:sldId id="261" r:id="rId7"/>
     <p:sldId id="262" r:id="rId8"/>
     <p:sldId id="263" r:id="rId9"/>
+    <p:sldId id="264" r:id="rId10"/>
   </p:sldIdLst>
   <p:sldSz cx="12192000" cy="6858000" type="wide"/>
   <p:notesSz cx="6858000" cy="9144000"/>
@@ -384,7 +385,44 @@
                 <a:latin typeface="Aptos"/>
                 <a:cs typeface="Aptos"/>
               </a:rPr>
-              <a:t>Проблема: single-node SignalR теряет события между узлами</a:t>
+              <a:t>Проблема и цель</a:t>
+            </a:r>
+          </a:p>
+        </p:txBody>
+      </p:sp>
+      <p:sp>
+        <p:nvSpPr>
+          <p:cNvPr id="11" name="Shape 11"/>
+          <p:cNvSpPr txBox="1"/>
+          <p:nvPr/>
+        </p:nvSpPr>
+        <p:spPr>
+          <a:xfrm>
+            <a:off x="621792" y="987552"/>
+            <a:ext cx="9875520" cy="320040"/>
+          </a:xfrm>
+          <a:prstGeom prst="roundRect">
+            <a:avLst/>
+          </a:prstGeom>
+          <a:noFill/>
+          <a:ln>
+            <a:noFill/>
+          </a:ln>
+        </p:spPr>
+        <p:txBody>
+          <a:bodyPr wrap="square" lIns="177800" tIns="177800" rIns="177800" bIns="177800"/>
+          <a:lstStyle/>
+          <a:p>
+            <a:pPr algn="l"/>
+            <a:r>
+              <a:rPr lang="ru-RU" sz="1300" b="0">
+                <a:solidFill>
+                  <a:srgbClr val="5E6A75"/>
+                </a:solidFill>
+                <a:latin typeface="Aptos"/>
+                <a:cs typeface="Aptos"/>
+              </a:rPr>
+              <a:t>Single-node SignalR ограничивает горизонтальное масштабирование</a:t>
             </a:r>
           </a:p>
         </p:txBody>
@@ -397,8 +435,8 @@
         </p:nvSpPr>
         <p:spPr>
           <a:xfrm>
-            <a:off x="685800" y="1554480"/>
-            <a:ext cx="5212080" cy="2377440"/>
+            <a:off x="685800" y="1508760"/>
+            <a:ext cx="5349240" cy="4206240"/>
           </a:xfrm>
           <a:prstGeom prst="roundRect">
             <a:avLst/>
@@ -418,40 +456,92 @@
           <a:p>
             <a:pPr algn="l"/>
             <a:r>
-              <a:rPr lang="ru-RU" sz="1800" b="0">
-                <a:solidFill>
-                  <a:srgbClr val="18212B"/>
-                </a:solidFill>
-                <a:latin typeface="Aptos"/>
-                <a:cs typeface="Aptos"/>
-              </a:rPr>
-              <a:t>Без межузлового канала</a:t>
-            </a:r>
-          </a:p>
-          <a:p>
-            <a:pPr algn="l"/>
-            <a:r>
-              <a:rPr lang="ru-RU" sz="1800" b="0">
-                <a:solidFill>
-                  <a:srgbClr val="18212B"/>
-                </a:solidFill>
-                <a:latin typeface="Aptos"/>
-                <a:cs typeface="Aptos"/>
-              </a:rPr>
-              <a:t>Каждый экземпляр знает только своих клиентов.</a:t>
-            </a:r>
-          </a:p>
-          <a:p>
-            <a:pPr algn="l"/>
-            <a:r>
-              <a:rPr lang="ru-RU" sz="1800" b="0">
-                <a:solidFill>
-                  <a:srgbClr val="18212B"/>
-                </a:solidFill>
-                <a:latin typeface="Aptos"/>
-                <a:cs typeface="Aptos"/>
-              </a:rPr>
-              <a:t>Событие, созданное на одном узле, не доходит до клиента на другом.</a:t>
+              <a:rPr lang="ru-RU" sz="1600" b="0">
+                <a:solidFill>
+                  <a:srgbClr val="18212B"/>
+                </a:solidFill>
+                <a:latin typeface="Aptos"/>
+                <a:cs typeface="Aptos"/>
+              </a:rPr>
+              <a:t>Проблема</a:t>
+            </a:r>
+          </a:p>
+          <a:p>
+            <a:pPr algn="l"/>
+            <a:r>
+              <a:rPr lang="ru-RU" sz="1600" b="0">
+                <a:solidFill>
+                  <a:srgbClr val="18212B"/>
+                </a:solidFill>
+                <a:latin typeface="Aptos"/>
+                <a:cs typeface="Aptos"/>
+              </a:rPr>
+              <a:t/>
+            </a:r>
+          </a:p>
+          <a:p>
+            <a:pPr algn="l"/>
+            <a:r>
+              <a:rPr lang="ru-RU" sz="1600" b="0">
+                <a:solidFill>
+                  <a:srgbClr val="18212B"/>
+                </a:solidFill>
+                <a:latin typeface="Aptos"/>
+                <a:cs typeface="Aptos"/>
+              </a:rPr>
+              <a:t>Сведения о подключениях и группах SignalR хранятся в памяти процесса.</a:t>
+            </a:r>
+          </a:p>
+          <a:p>
+            <a:pPr algn="l"/>
+            <a:r>
+              <a:rPr lang="ru-RU" sz="1600" b="0">
+                <a:solidFill>
+                  <a:srgbClr val="18212B"/>
+                </a:solidFill>
+                <a:latin typeface="Aptos"/>
+                <a:cs typeface="Aptos"/>
+              </a:rPr>
+              <a:t/>
+            </a:r>
+          </a:p>
+          <a:p>
+            <a:pPr algn="l"/>
+            <a:r>
+              <a:rPr lang="ru-RU" sz="1600" b="0">
+                <a:solidFill>
+                  <a:srgbClr val="18212B"/>
+                </a:solidFill>
+                <a:latin typeface="Aptos"/>
+                <a:cs typeface="Aptos"/>
+              </a:rPr>
+              <a:t>При нескольких экземплярах backend событие, созданное на одном узле, не доходит до клиента, подключенного к другому узлу.</a:t>
+            </a:r>
+          </a:p>
+          <a:p>
+            <a:pPr algn="l"/>
+            <a:r>
+              <a:rPr lang="ru-RU" sz="1600" b="0">
+                <a:solidFill>
+                  <a:srgbClr val="18212B"/>
+                </a:solidFill>
+                <a:latin typeface="Aptos"/>
+                <a:cs typeface="Aptos"/>
+              </a:rPr>
+              <a:t/>
+            </a:r>
+          </a:p>
+          <a:p>
+            <a:pPr algn="l"/>
+            <a:r>
+              <a:rPr lang="ru-RU" sz="1600" b="0">
+                <a:solidFill>
+                  <a:srgbClr val="18212B"/>
+                </a:solidFill>
+                <a:latin typeface="Aptos"/>
+                <a:cs typeface="Aptos"/>
+              </a:rPr>
+              <a:t>Real-time пространство фрагментируется на независимые острова.</a:t>
             </a:r>
           </a:p>
         </p:txBody>
@@ -464,8 +554,8 @@
         </p:nvSpPr>
         <p:spPr>
           <a:xfrm>
-            <a:off x="6172200" y="1554480"/>
-            <a:ext cx="5212080" cy="2377440"/>
+            <a:off x="6172200" y="1508760"/>
+            <a:ext cx="5349240" cy="4206240"/>
           </a:xfrm>
           <a:prstGeom prst="roundRect">
             <a:avLst/>
@@ -485,27 +575,40 @@
           <a:p>
             <a:pPr algn="l"/>
             <a:r>
-              <a:rPr lang="ru-RU" sz="1800" b="1">
-                <a:solidFill>
-                  <a:srgbClr val="18212B"/>
-                </a:solidFill>
-                <a:latin typeface="Aptos"/>
-                <a:cs typeface="Aptos"/>
-              </a:rPr>
-              <a:t>Цель работы</a:t>
-            </a:r>
-          </a:p>
-          <a:p>
-            <a:pPr algn="l"/>
-            <a:r>
-              <a:rPr lang="ru-RU" sz="1800" b="1">
-                <a:solidFill>
-                  <a:srgbClr val="18212B"/>
-                </a:solidFill>
-                <a:latin typeface="Aptos"/>
-                <a:cs typeface="Aptos"/>
-              </a:rPr>
-              <a:t>Восстановить корректную доставку событий между клиентами, подключенными к разным экземплярам backend-сервиса.</a:t>
+              <a:rPr lang="ru-RU" sz="1600" b="1">
+                <a:solidFill>
+                  <a:srgbClr val="18212B"/>
+                </a:solidFill>
+                <a:latin typeface="Aptos"/>
+                <a:cs typeface="Aptos"/>
+              </a:rPr>
+              <a:t>Цель преддипломной практики</a:t>
+            </a:r>
+          </a:p>
+          <a:p>
+            <a:pPr algn="l"/>
+            <a:r>
+              <a:rPr lang="ru-RU" sz="1600" b="1">
+                <a:solidFill>
+                  <a:srgbClr val="18212B"/>
+                </a:solidFill>
+                <a:latin typeface="Aptos"/>
+                <a:cs typeface="Aptos"/>
+              </a:rPr>
+              <a:t/>
+            </a:r>
+          </a:p>
+          <a:p>
+            <a:pPr algn="l"/>
+            <a:r>
+              <a:rPr lang="ru-RU" sz="1600" b="1">
+                <a:solidFill>
+                  <a:srgbClr val="18212B"/>
+                </a:solidFill>
+                <a:latin typeface="Aptos"/>
+                <a:cs typeface="Aptos"/>
+              </a:rPr>
+              <a:t>Real-time интерфейс системы отслеживания задач, в котором WebSocket-соединения обслуживаются несколькими экземплярами app-api, а события об изменении сущностей доставляются клиентам независимо от узла подключения.</a:t>
             </a:r>
           </a:p>
         </p:txBody>
@@ -612,7 +715,44 @@
                 <a:latin typeface="Aptos"/>
                 <a:cs typeface="Aptos"/>
               </a:rPr>
-              <a:t>Целевая архитектура</a:t>
+              <a:t>Анализ подходов к масштабированию</a:t>
+            </a:r>
+          </a:p>
+        </p:txBody>
+      </p:sp>
+      <p:sp>
+        <p:nvSpPr>
+          <p:cNvPr id="11" name="Shape 11"/>
+          <p:cNvSpPr txBox="1"/>
+          <p:nvPr/>
+        </p:nvSpPr>
+        <p:spPr>
+          <a:xfrm>
+            <a:off x="621792" y="987552"/>
+            <a:ext cx="9875520" cy="320040"/>
+          </a:xfrm>
+          <a:prstGeom prst="roundRect">
+            <a:avLst/>
+          </a:prstGeom>
+          <a:noFill/>
+          <a:ln>
+            <a:noFill/>
+          </a:ln>
+        </p:spPr>
+        <p:txBody>
+          <a:bodyPr wrap="square" lIns="177800" tIns="177800" rIns="177800" bIns="177800"/>
+          <a:lstStyle/>
+          <a:p>
+            <a:pPr algn="l"/>
+            <a:r>
+              <a:rPr lang="ru-RU" sz="1300" b="0">
+                <a:solidFill>
+                  <a:srgbClr val="5E6A75"/>
+                </a:solidFill>
+                <a:latin typeface="Aptos"/>
+                <a:cs typeface="Aptos"/>
+              </a:rPr>
+              <a:t>Шесть рассмотренных вариантов; обоснован выбор Redis backplane</a:t>
             </a:r>
           </a:p>
         </p:txBody>
@@ -625,8 +765,8 @@
         </p:nvSpPr>
         <p:spPr>
           <a:xfrm>
-            <a:off x="640080" y="1691640"/>
-            <a:ext cx="1828800" cy="640080"/>
+            <a:off x="685800" y="1554480"/>
+            <a:ext cx="3657600" cy="1325880"/>
           </a:xfrm>
           <a:prstGeom prst="roundRect">
             <a:avLst/>
@@ -644,16 +784,29 @@
           <a:bodyPr wrap="square" lIns="177800" tIns="177800" rIns="177800" bIns="177800"/>
           <a:lstStyle/>
           <a:p>
-            <a:pPr algn="ctr"/>
-            <a:r>
-              <a:rPr lang="ru-RU" sz="1400" b="1">
-                <a:solidFill>
-                  <a:srgbClr val="18212B"/>
-                </a:solidFill>
-                <a:latin typeface="Aptos"/>
-                <a:cs typeface="Aptos"/>
-              </a:rPr>
-              <a:t>Клиент A</a:t>
+            <a:pPr algn="l"/>
+            <a:r>
+              <a:rPr lang="ru-RU" sz="1300" b="0">
+                <a:solidFill>
+                  <a:srgbClr val="18212B"/>
+                </a:solidFill>
+                <a:latin typeface="Aptos"/>
+                <a:cs typeface="Aptos"/>
+              </a:rPr>
+              <a:t>Один экземпляр backend</a:t>
+            </a:r>
+          </a:p>
+          <a:p>
+            <a:pPr algn="l"/>
+            <a:r>
+              <a:rPr lang="ru-RU" sz="1300" b="0">
+                <a:solidFill>
+                  <a:srgbClr val="18212B"/>
+                </a:solidFill>
+                <a:latin typeface="Aptos"/>
+                <a:cs typeface="Aptos"/>
+              </a:rPr>
+              <a:t>Нет масштабирования; один узел — точка отказа</a:t>
             </a:r>
           </a:p>
         </p:txBody>
@@ -666,8 +819,8 @@
         </p:nvSpPr>
         <p:spPr>
           <a:xfrm>
-            <a:off x="640080" y="3246120"/>
-            <a:ext cx="1828800" cy="640080"/>
+            <a:off x="4434840" y="1554480"/>
+            <a:ext cx="3657600" cy="1325880"/>
           </a:xfrm>
           <a:prstGeom prst="roundRect">
             <a:avLst/>
@@ -685,16 +838,29 @@
           <a:bodyPr wrap="square" lIns="177800" tIns="177800" rIns="177800" bIns="177800"/>
           <a:lstStyle/>
           <a:p>
-            <a:pPr algn="ctr"/>
-            <a:r>
-              <a:rPr lang="ru-RU" sz="1400" b="1">
-                <a:solidFill>
-                  <a:srgbClr val="18212B"/>
-                </a:solidFill>
-                <a:latin typeface="Aptos"/>
-                <a:cs typeface="Aptos"/>
-              </a:rPr>
-              <a:t>Клиент B</a:t>
+            <a:pPr algn="l"/>
+            <a:r>
+              <a:rPr lang="ru-RU" sz="1300" b="0">
+                <a:solidFill>
+                  <a:srgbClr val="18212B"/>
+                </a:solidFill>
+                <a:latin typeface="Aptos"/>
+                <a:cs typeface="Aptos"/>
+              </a:rPr>
+              <a:t>Несколько экземпляров без backplane</a:t>
+            </a:r>
+          </a:p>
+          <a:p>
+            <a:pPr algn="l"/>
+            <a:r>
+              <a:rPr lang="ru-RU" sz="1300" b="0">
+                <a:solidFill>
+                  <a:srgbClr val="18212B"/>
+                </a:solidFill>
+                <a:latin typeface="Aptos"/>
+                <a:cs typeface="Aptos"/>
+              </a:rPr>
+              <a:t>Real-time пространство фрагментируется по узлам</a:t>
             </a:r>
           </a:p>
         </p:txBody>
@@ -707,8 +873,170 @@
         </p:nvSpPr>
         <p:spPr>
           <a:xfrm>
-            <a:off x="3108960" y="2468880"/>
-            <a:ext cx="1554480" cy="777240"/>
+            <a:off x="8183880" y="1554480"/>
+            <a:ext cx="3657600" cy="1325880"/>
+          </a:xfrm>
+          <a:prstGeom prst="roundRect">
+            <a:avLst/>
+          </a:prstGeom>
+          <a:solidFill>
+            <a:srgbClr val="FFFFFF"/>
+          </a:solidFill>
+          <a:ln w="12700">
+            <a:solidFill>
+              <a:srgbClr val="D7D2C7"/>
+            </a:solidFill>
+          </a:ln>
+        </p:spPr>
+        <p:txBody>
+          <a:bodyPr wrap="square" lIns="177800" tIns="177800" rIns="177800" bIns="177800"/>
+          <a:lstStyle/>
+          <a:p>
+            <a:pPr algn="l"/>
+            <a:r>
+              <a:rPr lang="ru-RU" sz="1300" b="0">
+                <a:solidFill>
+                  <a:srgbClr val="18212B"/>
+                </a:solidFill>
+                <a:latin typeface="Aptos"/>
+                <a:cs typeface="Aptos"/>
+              </a:rPr>
+              <a:t>Sticky sessions</a:t>
+            </a:r>
+          </a:p>
+          <a:p>
+            <a:pPr algn="l"/>
+            <a:r>
+              <a:rPr lang="ru-RU" sz="1300" b="0">
+                <a:solidFill>
+                  <a:srgbClr val="18212B"/>
+                </a:solidFill>
+                <a:latin typeface="Aptos"/>
+                <a:cs typeface="Aptos"/>
+              </a:rPr>
+              <a:t>Удерживают клиента на узле, но не доставляют события на другие</a:t>
+            </a:r>
+          </a:p>
+        </p:txBody>
+      </p:sp>
+      <p:sp>
+        <p:nvSpPr>
+          <p:cNvPr id="23" name="Shape 23"/>
+          <p:cNvSpPr txBox="1"/>
+          <p:nvPr/>
+        </p:nvSpPr>
+        <p:spPr>
+          <a:xfrm>
+            <a:off x="685800" y="3017520"/>
+            <a:ext cx="3657600" cy="1325880"/>
+          </a:xfrm>
+          <a:prstGeom prst="roundRect">
+            <a:avLst/>
+          </a:prstGeom>
+          <a:solidFill>
+            <a:srgbClr val="FFFFFF"/>
+          </a:solidFill>
+          <a:ln w="12700">
+            <a:solidFill>
+              <a:srgbClr val="D7D2C7"/>
+            </a:solidFill>
+          </a:ln>
+        </p:spPr>
+        <p:txBody>
+          <a:bodyPr wrap="square" lIns="177800" tIns="177800" rIns="177800" bIns="177800"/>
+          <a:lstStyle/>
+          <a:p>
+            <a:pPr algn="l"/>
+            <a:r>
+              <a:rPr lang="ru-RU" sz="1300" b="0">
+                <a:solidFill>
+                  <a:srgbClr val="18212B"/>
+                </a:solidFill>
+                <a:latin typeface="Aptos"/>
+                <a:cs typeface="Aptos"/>
+              </a:rPr>
+              <a:t>Broker / event bus</a:t>
+            </a:r>
+          </a:p>
+          <a:p>
+            <a:pPr algn="l"/>
+            <a:r>
+              <a:rPr lang="ru-RU" sz="1300" b="0">
+                <a:solidFill>
+                  <a:srgbClr val="18212B"/>
+                </a:solidFill>
+                <a:latin typeface="Aptos"/>
+                <a:cs typeface="Aptos"/>
+              </a:rPr>
+              <a:t>Даёт межузловую доставку, но требует схем событий и persistence</a:t>
+            </a:r>
+          </a:p>
+        </p:txBody>
+      </p:sp>
+      <p:sp>
+        <p:nvSpPr>
+          <p:cNvPr id="24" name="Shape 24"/>
+          <p:cNvSpPr txBox="1"/>
+          <p:nvPr/>
+        </p:nvSpPr>
+        <p:spPr>
+          <a:xfrm>
+            <a:off x="4434840" y="3017520"/>
+            <a:ext cx="3657600" cy="1325880"/>
+          </a:xfrm>
+          <a:prstGeom prst="roundRect">
+            <a:avLst/>
+          </a:prstGeom>
+          <a:solidFill>
+            <a:srgbClr val="FFFFFF"/>
+          </a:solidFill>
+          <a:ln w="12700">
+            <a:solidFill>
+              <a:srgbClr val="D7D2C7"/>
+            </a:solidFill>
+          </a:ln>
+        </p:spPr>
+        <p:txBody>
+          <a:bodyPr wrap="square" lIns="177800" tIns="177800" rIns="177800" bIns="177800"/>
+          <a:lstStyle/>
+          <a:p>
+            <a:pPr algn="l"/>
+            <a:r>
+              <a:rPr lang="ru-RU" sz="1300" b="0">
+                <a:solidFill>
+                  <a:srgbClr val="18212B"/>
+                </a:solidFill>
+                <a:latin typeface="Aptos"/>
+                <a:cs typeface="Aptos"/>
+              </a:rPr>
+              <a:t>Managed real-time service</a:t>
+            </a:r>
+          </a:p>
+          <a:p>
+            <a:pPr algn="l"/>
+            <a:r>
+              <a:rPr lang="ru-RU" sz="1300" b="0">
+                <a:solidFill>
+                  <a:srgbClr val="18212B"/>
+                </a:solidFill>
+                <a:latin typeface="Aptos"/>
+                <a:cs typeface="Aptos"/>
+              </a:rPr>
+              <a:t>Уменьшает контроль над self-hosted контуром</a:t>
+            </a:r>
+          </a:p>
+        </p:txBody>
+      </p:sp>
+      <p:sp>
+        <p:nvSpPr>
+          <p:cNvPr id="25" name="Shape 25"/>
+          <p:cNvSpPr txBox="1"/>
+          <p:nvPr/>
+        </p:nvSpPr>
+        <p:spPr>
+          <a:xfrm>
+            <a:off x="8183880" y="3017520"/>
+            <a:ext cx="3657600" cy="1325880"/>
           </a:xfrm>
           <a:prstGeom prst="roundRect">
             <a:avLst/>
@@ -726,139 +1054,29 @@
           <a:bodyPr wrap="square" lIns="177800" tIns="177800" rIns="177800" bIns="177800"/>
           <a:lstStyle/>
           <a:p>
-            <a:pPr algn="ctr"/>
-            <a:r>
-              <a:rPr lang="ru-RU" sz="1400" b="1">
-                <a:solidFill>
-                  <a:srgbClr val="18212B"/>
-                </a:solidFill>
-                <a:latin typeface="Aptos"/>
-                <a:cs typeface="Aptos"/>
-              </a:rPr>
-              <a:t>nginx</a:t>
-            </a:r>
-          </a:p>
-        </p:txBody>
-      </p:sp>
-      <p:sp>
-        <p:nvSpPr>
-          <p:cNvPr id="23" name="Shape 23"/>
-          <p:cNvSpPr txBox="1"/>
-          <p:nvPr/>
-        </p:nvSpPr>
-        <p:spPr>
-          <a:xfrm>
-            <a:off x="5303520" y="1691640"/>
-            <a:ext cx="1920240" cy="640080"/>
-          </a:xfrm>
-          <a:prstGeom prst="roundRect">
-            <a:avLst/>
-          </a:prstGeom>
-          <a:solidFill>
-            <a:srgbClr val="FFFFFF"/>
-          </a:solidFill>
-          <a:ln w="12700">
-            <a:solidFill>
-              <a:srgbClr val="D7D2C7"/>
-            </a:solidFill>
-          </a:ln>
-        </p:spPr>
-        <p:txBody>
-          <a:bodyPr wrap="square" lIns="177800" tIns="177800" rIns="177800" bIns="177800"/>
-          <a:lstStyle/>
-          <a:p>
-            <a:pPr algn="ctr"/>
-            <a:r>
-              <a:rPr lang="ru-RU" sz="1400" b="1">
-                <a:solidFill>
-                  <a:srgbClr val="18212B"/>
-                </a:solidFill>
-                <a:latin typeface="Aptos"/>
-                <a:cs typeface="Aptos"/>
-              </a:rPr>
-              <a:t>app-api-1</a:t>
-            </a:r>
-          </a:p>
-        </p:txBody>
-      </p:sp>
-      <p:sp>
-        <p:nvSpPr>
-          <p:cNvPr id="24" name="Shape 24"/>
-          <p:cNvSpPr txBox="1"/>
-          <p:nvPr/>
-        </p:nvSpPr>
-        <p:spPr>
-          <a:xfrm>
-            <a:off x="5303520" y="3246120"/>
-            <a:ext cx="1920240" cy="640080"/>
-          </a:xfrm>
-          <a:prstGeom prst="roundRect">
-            <a:avLst/>
-          </a:prstGeom>
-          <a:solidFill>
-            <a:srgbClr val="FFFFFF"/>
-          </a:solidFill>
-          <a:ln w="12700">
-            <a:solidFill>
-              <a:srgbClr val="D7D2C7"/>
-            </a:solidFill>
-          </a:ln>
-        </p:spPr>
-        <p:txBody>
-          <a:bodyPr wrap="square" lIns="177800" tIns="177800" rIns="177800" bIns="177800"/>
-          <a:lstStyle/>
-          <a:p>
-            <a:pPr algn="ctr"/>
-            <a:r>
-              <a:rPr lang="ru-RU" sz="1400" b="1">
-                <a:solidFill>
-                  <a:srgbClr val="18212B"/>
-                </a:solidFill>
-                <a:latin typeface="Aptos"/>
-                <a:cs typeface="Aptos"/>
-              </a:rPr>
-              <a:t>app-api-2</a:t>
-            </a:r>
-          </a:p>
-        </p:txBody>
-      </p:sp>
-      <p:sp>
-        <p:nvSpPr>
-          <p:cNvPr id="25" name="Shape 25"/>
-          <p:cNvSpPr txBox="1"/>
-          <p:nvPr/>
-        </p:nvSpPr>
-        <p:spPr>
-          <a:xfrm>
-            <a:off x="7818120" y="2468880"/>
-            <a:ext cx="2286000" cy="777240"/>
-          </a:xfrm>
-          <a:prstGeom prst="roundRect">
-            <a:avLst/>
-          </a:prstGeom>
-          <a:solidFill>
-            <a:srgbClr val="E8F3F1"/>
-          </a:solidFill>
-          <a:ln w="12700">
-            <a:solidFill>
-              <a:srgbClr val="0B6E69"/>
-            </a:solidFill>
-          </a:ln>
-        </p:spPr>
-        <p:txBody>
-          <a:bodyPr wrap="square" lIns="177800" tIns="177800" rIns="177800" bIns="177800"/>
-          <a:lstStyle/>
-          <a:p>
-            <a:pPr algn="ctr"/>
-            <a:r>
-              <a:rPr lang="ru-RU" sz="1400" b="1">
-                <a:solidFill>
-                  <a:srgbClr val="18212B"/>
-                </a:solidFill>
-                <a:latin typeface="Aptos"/>
-                <a:cs typeface="Aptos"/>
-              </a:rPr>
-              <a:t>Redis backplane</a:t>
+            <a:pPr algn="l"/>
+            <a:r>
+              <a:rPr lang="ru-RU" sz="1300" b="1">
+                <a:solidFill>
+                  <a:srgbClr val="18212B"/>
+                </a:solidFill>
+                <a:latin typeface="Aptos"/>
+                <a:cs typeface="Aptos"/>
+              </a:rPr>
+              <a:t>Redis backplane для SignalR — выбрано</a:t>
+            </a:r>
+          </a:p>
+          <a:p>
+            <a:pPr algn="l"/>
+            <a:r>
+              <a:rPr lang="ru-RU" sz="1300" b="1">
+                <a:solidFill>
+                  <a:srgbClr val="18212B"/>
+                </a:solidFill>
+                <a:latin typeface="Aptos"/>
+                <a:cs typeface="Aptos"/>
+              </a:rPr>
+              <a:t>self-hosted, без перестройки логики, transient pub/sub</a:t>
             </a:r>
           </a:p>
         </p:txBody>
@@ -871,8 +1089,8 @@
         </p:nvSpPr>
         <p:spPr>
           <a:xfrm>
-            <a:off x="640080" y="4754880"/>
-            <a:ext cx="10515600" cy="502920"/>
+            <a:off x="685800" y="4617720"/>
+            <a:ext cx="11155680" cy="1280160"/>
           </a:xfrm>
           <a:prstGeom prst="roundRect">
             <a:avLst/>
@@ -886,16 +1104,16 @@
           <a:bodyPr wrap="square" lIns="177800" tIns="177800" rIns="177800" bIns="177800"/>
           <a:lstStyle/>
           <a:p>
-            <a:pPr algn="ctr"/>
-            <a:r>
-              <a:rPr lang="ru-RU" sz="1400" b="0">
+            <a:pPr algn="l"/>
+            <a:r>
+              <a:rPr lang="ru-RU" sz="1200" b="0">
                 <a:solidFill>
                   <a:srgbClr val="5E6A75"/>
                 </a:solidFill>
                 <a:latin typeface="Aptos"/>
                 <a:cs typeface="Aptos"/>
               </a:rPr>
-              <a:t>SignalR-события публикуются между экземплярами через Redis; группы остаются локальным runtime-состоянием.</a:t>
+              <a:t>Критерии выбора: совместимость с self-hosted стендом, минимальная перестройка доменной логики, наличие штатной поддержки в ASP.NET Core SignalR, пригодность для transient UI-событий и воспроизводимость на локальном Docker Compose стенде.</a:t>
             </a:r>
           </a:p>
         </p:txBody>
@@ -1002,7 +1220,44 @@
                 <a:latin typeface="Aptos"/>
                 <a:cs typeface="Aptos"/>
               </a:rPr>
-              <a:t>Что сделано</a:t>
+              <a:t>Целевая архитектура</a:t>
+            </a:r>
+          </a:p>
+        </p:txBody>
+      </p:sp>
+      <p:sp>
+        <p:nvSpPr>
+          <p:cNvPr id="11" name="Shape 11"/>
+          <p:cNvSpPr txBox="1"/>
+          <p:nvPr/>
+        </p:nvSpPr>
+        <p:spPr>
+          <a:xfrm>
+            <a:off x="621792" y="987552"/>
+            <a:ext cx="9875520" cy="320040"/>
+          </a:xfrm>
+          <a:prstGeom prst="roundRect">
+            <a:avLst/>
+          </a:prstGeom>
+          <a:noFill/>
+          <a:ln>
+            <a:noFill/>
+          </a:ln>
+        </p:spPr>
+        <p:txBody>
+          <a:bodyPr wrap="square" lIns="177800" tIns="177800" rIns="177800" bIns="177800"/>
+          <a:lstStyle/>
+          <a:p>
+            <a:pPr algn="l"/>
+            <a:r>
+              <a:rPr lang="ru-RU" sz="1300" b="0">
+                <a:solidFill>
+                  <a:srgbClr val="5E6A75"/>
+                </a:solidFill>
+                <a:latin typeface="Aptos"/>
+                <a:cs typeface="Aptos"/>
+              </a:rPr>
+              <a:t>Два экземпляра app-api за nginx, общий Redis backplane для межузловой доставки</a:t>
             </a:r>
           </a:p>
         </p:txBody>
@@ -1015,8 +1270,8 @@
         </p:nvSpPr>
         <p:spPr>
           <a:xfrm>
-            <a:off x="685800" y="1554480"/>
-            <a:ext cx="5212080" cy="1097280"/>
+            <a:off x="914400" y="1874520"/>
+            <a:ext cx="1645920" cy="640080"/>
           </a:xfrm>
           <a:prstGeom prst="roundRect">
             <a:avLst/>
@@ -1034,29 +1289,16 @@
           <a:bodyPr wrap="square" lIns="177800" tIns="177800" rIns="177800" bIns="177800"/>
           <a:lstStyle/>
           <a:p>
-            <a:pPr algn="l"/>
-            <a:r>
-              <a:rPr lang="ru-RU" sz="1500" b="0">
-                <a:solidFill>
-                  <a:srgbClr val="18212B"/>
-                </a:solidFill>
-                <a:latin typeface="Aptos"/>
-                <a:cs typeface="Aptos"/>
-              </a:rPr>
-              <a:t>1 · Redis backplane для SignalR</a:t>
-            </a:r>
-          </a:p>
-          <a:p>
-            <a:pPr algn="l"/>
-            <a:r>
-              <a:rPr lang="ru-RU" sz="1500" b="0">
-                <a:solidFill>
-                  <a:srgbClr val="18212B"/>
-                </a:solidFill>
-                <a:latin typeface="Aptos"/>
-                <a:cs typeface="Aptos"/>
-              </a:rPr>
-              <a:t>Конфигурируется через REDIS_CONNECTION_STRING</a:t>
+            <a:pPr algn="ctr"/>
+            <a:r>
+              <a:rPr lang="ru-RU" sz="1400" b="1">
+                <a:solidFill>
+                  <a:srgbClr val="18212B"/>
+                </a:solidFill>
+                <a:latin typeface="Aptos"/>
+                <a:cs typeface="Aptos"/>
+              </a:rPr>
+              <a:t>Клиент A</a:t>
             </a:r>
           </a:p>
         </p:txBody>
@@ -1069,8 +1311,8 @@
         </p:nvSpPr>
         <p:spPr>
           <a:xfrm>
-            <a:off x="685800" y="2743200"/>
-            <a:ext cx="5212080" cy="1097280"/>
+            <a:off x="914400" y="3749040"/>
+            <a:ext cx="1645920" cy="640080"/>
           </a:xfrm>
           <a:prstGeom prst="roundRect">
             <a:avLst/>
@@ -1088,29 +1330,16 @@
           <a:bodyPr wrap="square" lIns="177800" tIns="177800" rIns="177800" bIns="177800"/>
           <a:lstStyle/>
           <a:p>
-            <a:pPr algn="l"/>
-            <a:r>
-              <a:rPr lang="ru-RU" sz="1500" b="0">
-                <a:solidFill>
-                  <a:srgbClr val="18212B"/>
-                </a:solidFill>
-                <a:latin typeface="Aptos"/>
-                <a:cs typeface="Aptos"/>
-              </a:rPr>
-              <a:t>2 · Диагностика узла</a:t>
-            </a:r>
-          </a:p>
-          <a:p>
-            <a:pPr algn="l"/>
-            <a:r>
-              <a:rPr lang="ru-RU" sz="1500" b="0">
-                <a:solidFill>
-                  <a:srgbClr val="18212B"/>
-                </a:solidFill>
-                <a:latin typeface="Aptos"/>
-                <a:cs typeface="Aptos"/>
-              </a:rPr>
-              <a:t>SERVER_INSTANCE_ID, connectionId, machineName</a:t>
+            <a:pPr algn="ctr"/>
+            <a:r>
+              <a:rPr lang="ru-RU" sz="1400" b="1">
+                <a:solidFill>
+                  <a:srgbClr val="18212B"/>
+                </a:solidFill>
+                <a:latin typeface="Aptos"/>
+                <a:cs typeface="Aptos"/>
+              </a:rPr>
+              <a:t>Клиент B</a:t>
             </a:r>
           </a:p>
         </p:txBody>
@@ -1123,8 +1352,49 @@
         </p:nvSpPr>
         <p:spPr>
           <a:xfrm>
-            <a:off x="6172200" y="1554480"/>
-            <a:ext cx="5212080" cy="1097280"/>
+            <a:off x="3291840" y="2788920"/>
+            <a:ext cx="1371600" cy="731520"/>
+          </a:xfrm>
+          <a:prstGeom prst="roundRect">
+            <a:avLst/>
+          </a:prstGeom>
+          <a:solidFill>
+            <a:srgbClr val="E8F3F1"/>
+          </a:solidFill>
+          <a:ln w="12700">
+            <a:solidFill>
+              <a:srgbClr val="0B6E69"/>
+            </a:solidFill>
+          </a:ln>
+        </p:spPr>
+        <p:txBody>
+          <a:bodyPr wrap="square" lIns="177800" tIns="177800" rIns="177800" bIns="177800"/>
+          <a:lstStyle/>
+          <a:p>
+            <a:pPr algn="ctr"/>
+            <a:r>
+              <a:rPr lang="ru-RU" sz="1400" b="1">
+                <a:solidFill>
+                  <a:srgbClr val="18212B"/>
+                </a:solidFill>
+                <a:latin typeface="Aptos"/>
+                <a:cs typeface="Aptos"/>
+              </a:rPr>
+              <a:t>nginx</a:t>
+            </a:r>
+          </a:p>
+        </p:txBody>
+      </p:sp>
+      <p:sp>
+        <p:nvSpPr>
+          <p:cNvPr id="23" name="Shape 23"/>
+          <p:cNvSpPr txBox="1"/>
+          <p:nvPr/>
+        </p:nvSpPr>
+        <p:spPr>
+          <a:xfrm>
+            <a:off x="5577840" y="1874520"/>
+            <a:ext cx="1828800" cy="640080"/>
           </a:xfrm>
           <a:prstGeom prst="roundRect">
             <a:avLst/>
@@ -1134,7 +1404,7 @@
           </a:solidFill>
           <a:ln w="12700">
             <a:solidFill>
-              <a:srgbClr val="D7D2C7"/>
+              <a:srgbClr val="0B6E69"/>
             </a:solidFill>
           </a:ln>
         </p:spPr>
@@ -1142,43 +1412,30 @@
           <a:bodyPr wrap="square" lIns="177800" tIns="177800" rIns="177800" bIns="177800"/>
           <a:lstStyle/>
           <a:p>
-            <a:pPr algn="l"/>
-            <a:r>
-              <a:rPr lang="ru-RU" sz="1500" b="0">
-                <a:solidFill>
-                  <a:srgbClr val="18212B"/>
-                </a:solidFill>
-                <a:latin typeface="Aptos"/>
-                <a:cs typeface="Aptos"/>
-              </a:rPr>
-              <a:t>3 · Стенд Docker Compose</a:t>
-            </a:r>
-          </a:p>
-          <a:p>
-            <a:pPr algn="l"/>
-            <a:r>
-              <a:rPr lang="ru-RU" sz="1500" b="0">
-                <a:solidFill>
-                  <a:srgbClr val="18212B"/>
-                </a:solidFill>
-                <a:latin typeface="Aptos"/>
-                <a:cs typeface="Aptos"/>
-              </a:rPr>
-              <a:t>app-api-1, app-api-2, Redis, PostgreSQL, nginx</a:t>
-            </a:r>
-          </a:p>
-        </p:txBody>
-      </p:sp>
-      <p:sp>
-        <p:nvSpPr>
-          <p:cNvPr id="23" name="Shape 23"/>
-          <p:cNvSpPr txBox="1"/>
-          <p:nvPr/>
-        </p:nvSpPr>
-        <p:spPr>
-          <a:xfrm>
-            <a:off x="6172200" y="2743200"/>
-            <a:ext cx="5212080" cy="1097280"/>
+            <a:pPr algn="ctr"/>
+            <a:r>
+              <a:rPr lang="ru-RU" sz="1400" b="1">
+                <a:solidFill>
+                  <a:srgbClr val="18212B"/>
+                </a:solidFill>
+                <a:latin typeface="Aptos"/>
+                <a:cs typeface="Aptos"/>
+              </a:rPr>
+              <a:t>app-api-1</a:t>
+            </a:r>
+          </a:p>
+        </p:txBody>
+      </p:sp>
+      <p:sp>
+        <p:nvSpPr>
+          <p:cNvPr id="24" name="Shape 24"/>
+          <p:cNvSpPr txBox="1"/>
+          <p:nvPr/>
+        </p:nvSpPr>
+        <p:spPr>
+          <a:xfrm>
+            <a:off x="5577840" y="3749040"/>
+            <a:ext cx="1828800" cy="640080"/>
           </a:xfrm>
           <a:prstGeom prst="roundRect">
             <a:avLst/>
@@ -1188,7 +1445,7 @@
           </a:solidFill>
           <a:ln w="12700">
             <a:solidFill>
-              <a:srgbClr val="D7D2C7"/>
+              <a:srgbClr val="0B6E69"/>
             </a:solidFill>
           </a:ln>
         </p:spPr>
@@ -1196,29 +1453,265 @@
           <a:bodyPr wrap="square" lIns="177800" tIns="177800" rIns="177800" bIns="177800"/>
           <a:lstStyle/>
           <a:p>
-            <a:pPr algn="l"/>
-            <a:r>
-              <a:rPr lang="ru-RU" sz="1500" b="0">
-                <a:solidFill>
-                  <a:srgbClr val="18212B"/>
-                </a:solidFill>
-                <a:latin typeface="Aptos"/>
-                <a:cs typeface="Aptos"/>
-              </a:rPr>
-              <a:t>4 · Node.js-клиент</a:t>
-            </a:r>
-          </a:p>
-          <a:p>
-            <a:pPr algn="l"/>
-            <a:r>
-              <a:rPr lang="ru-RU" sz="1500" b="0">
-                <a:solidFill>
-                  <a:srgbClr val="18212B"/>
-                </a:solidFill>
-                <a:latin typeface="Aptos"/>
-                <a:cs typeface="Aptos"/>
-              </a:rPr>
-              <a:t>Delivery, серия, rejoin, failover</a:t>
+            <a:pPr algn="ctr"/>
+            <a:r>
+              <a:rPr lang="ru-RU" sz="1400" b="1">
+                <a:solidFill>
+                  <a:srgbClr val="18212B"/>
+                </a:solidFill>
+                <a:latin typeface="Aptos"/>
+                <a:cs typeface="Aptos"/>
+              </a:rPr>
+              <a:t>app-api-2</a:t>
+            </a:r>
+          </a:p>
+        </p:txBody>
+      </p:sp>
+      <p:sp>
+        <p:nvSpPr>
+          <p:cNvPr id="25" name="Shape 25"/>
+          <p:cNvSpPr txBox="1"/>
+          <p:nvPr/>
+        </p:nvSpPr>
+        <p:spPr>
+          <a:xfrm>
+            <a:off x="8321040" y="2788920"/>
+            <a:ext cx="2194560" cy="731520"/>
+          </a:xfrm>
+          <a:prstGeom prst="roundRect">
+            <a:avLst/>
+          </a:prstGeom>
+          <a:solidFill>
+            <a:srgbClr val="E8F3F1"/>
+          </a:solidFill>
+          <a:ln w="12700">
+            <a:solidFill>
+              <a:srgbClr val="0B6E69"/>
+            </a:solidFill>
+          </a:ln>
+        </p:spPr>
+        <p:txBody>
+          <a:bodyPr wrap="square" lIns="177800" tIns="177800" rIns="177800" bIns="177800"/>
+          <a:lstStyle/>
+          <a:p>
+            <a:pPr algn="ctr"/>
+            <a:r>
+              <a:rPr lang="ru-RU" sz="1400" b="1">
+                <a:solidFill>
+                  <a:srgbClr val="18212B"/>
+                </a:solidFill>
+                <a:latin typeface="Aptos"/>
+                <a:cs typeface="Aptos"/>
+              </a:rPr>
+              <a:t>Redis backplane</a:t>
+            </a:r>
+          </a:p>
+        </p:txBody>
+      </p:sp>
+      <p:cxnSp>
+        <p:nvCxnSpPr>
+          <p:cNvPr id="50" name="Connector 50"/>
+          <p:cNvCxnSpPr/>
+          <p:nvPr/>
+        </p:nvCxnSpPr>
+        <p:spPr>
+          <a:xfrm flipH="0" flipV="0">
+            <a:off x="2560320" y="2194560"/>
+            <a:ext cx="731520" cy="795528"/>
+          </a:xfrm>
+          <a:prstGeom prst="straightConnector1">
+            <a:avLst/>
+          </a:prstGeom>
+          <a:ln w="15875" cap="flat">
+            <a:solidFill>
+              <a:srgbClr val="0B6E69"/>
+            </a:solidFill>
+            <a:tailEnd type="triangle"/>
+          </a:ln>
+        </p:spPr>
+      </p:cxnSp>
+      <p:cxnSp>
+        <p:nvCxnSpPr>
+          <p:cNvPr id="51" name="Connector 51"/>
+          <p:cNvCxnSpPr/>
+          <p:nvPr/>
+        </p:nvCxnSpPr>
+        <p:spPr>
+          <a:xfrm flipH="0" flipV="1">
+            <a:off x="2560320" y="3319272"/>
+            <a:ext cx="731520" cy="749808"/>
+          </a:xfrm>
+          <a:prstGeom prst="straightConnector1">
+            <a:avLst/>
+          </a:prstGeom>
+          <a:ln w="15875" cap="flat">
+            <a:solidFill>
+              <a:srgbClr val="0B6E69"/>
+            </a:solidFill>
+            <a:tailEnd type="triangle"/>
+          </a:ln>
+        </p:spPr>
+      </p:cxnSp>
+      <p:cxnSp>
+        <p:nvCxnSpPr>
+          <p:cNvPr id="52" name="Connector 52"/>
+          <p:cNvCxnSpPr/>
+          <p:nvPr/>
+        </p:nvCxnSpPr>
+        <p:spPr>
+          <a:xfrm flipH="0" flipV="1">
+            <a:off x="4663440" y="2194560"/>
+            <a:ext cx="914400" cy="795528"/>
+          </a:xfrm>
+          <a:prstGeom prst="straightConnector1">
+            <a:avLst/>
+          </a:prstGeom>
+          <a:ln w="15875" cap="flat">
+            <a:solidFill>
+              <a:srgbClr val="0B6E69"/>
+            </a:solidFill>
+            <a:tailEnd type="triangle"/>
+          </a:ln>
+        </p:spPr>
+      </p:cxnSp>
+      <p:cxnSp>
+        <p:nvCxnSpPr>
+          <p:cNvPr id="53" name="Connector 53"/>
+          <p:cNvCxnSpPr/>
+          <p:nvPr/>
+        </p:nvCxnSpPr>
+        <p:spPr>
+          <a:xfrm flipH="0" flipV="0">
+            <a:off x="4663440" y="3319272"/>
+            <a:ext cx="914400" cy="749808"/>
+          </a:xfrm>
+          <a:prstGeom prst="straightConnector1">
+            <a:avLst/>
+          </a:prstGeom>
+          <a:ln w="15875" cap="flat">
+            <a:solidFill>
+              <a:srgbClr val="0B6E69"/>
+            </a:solidFill>
+            <a:tailEnd type="triangle"/>
+          </a:ln>
+        </p:spPr>
+      </p:cxnSp>
+      <p:cxnSp>
+        <p:nvCxnSpPr>
+          <p:cNvPr id="54" name="Connector 54"/>
+          <p:cNvCxnSpPr/>
+          <p:nvPr/>
+        </p:nvCxnSpPr>
+        <p:spPr>
+          <a:xfrm flipH="0" flipV="0">
+            <a:off x="7406640" y="2194560"/>
+            <a:ext cx="914400" cy="795528"/>
+          </a:xfrm>
+          <a:prstGeom prst="straightConnector1">
+            <a:avLst/>
+          </a:prstGeom>
+          <a:ln w="15875" cap="flat">
+            <a:solidFill>
+              <a:srgbClr val="0B6E69"/>
+            </a:solidFill>
+            <a:headEnd type="triangle"/>
+            <a:tailEnd type="triangle"/>
+          </a:ln>
+        </p:spPr>
+      </p:cxnSp>
+      <p:cxnSp>
+        <p:nvCxnSpPr>
+          <p:cNvPr id="55" name="Connector 55"/>
+          <p:cNvCxnSpPr/>
+          <p:nvPr/>
+        </p:nvCxnSpPr>
+        <p:spPr>
+          <a:xfrm flipH="0" flipV="1">
+            <a:off x="7406640" y="3319272"/>
+            <a:ext cx="914400" cy="749808"/>
+          </a:xfrm>
+          <a:prstGeom prst="straightConnector1">
+            <a:avLst/>
+          </a:prstGeom>
+          <a:ln w="15875" cap="flat">
+            <a:solidFill>
+              <a:srgbClr val="0B6E69"/>
+            </a:solidFill>
+            <a:headEnd type="triangle"/>
+            <a:tailEnd type="triangle"/>
+          </a:ln>
+        </p:spPr>
+      </p:cxnSp>
+      <p:sp>
+        <p:nvSpPr>
+          <p:cNvPr id="26" name="Shape 26"/>
+          <p:cNvSpPr txBox="1"/>
+          <p:nvPr/>
+        </p:nvSpPr>
+        <p:spPr>
+          <a:xfrm>
+            <a:off x="640080" y="4937760"/>
+            <a:ext cx="10972800" cy="457200"/>
+          </a:xfrm>
+          <a:prstGeom prst="roundRect">
+            <a:avLst/>
+          </a:prstGeom>
+          <a:noFill/>
+          <a:ln>
+            <a:noFill/>
+          </a:ln>
+        </p:spPr>
+        <p:txBody>
+          <a:bodyPr wrap="square" lIns="177800" tIns="177800" rIns="177800" bIns="177800"/>
+          <a:lstStyle/>
+          <a:p>
+            <a:pPr algn="ctr"/>
+            <a:r>
+              <a:rPr lang="ru-RU" sz="1300" b="0">
+                <a:solidFill>
+                  <a:srgbClr val="5E6A75"/>
+                </a:solidFill>
+                <a:latin typeface="Aptos"/>
+                <a:cs typeface="Aptos"/>
+              </a:rPr>
+              <a:t>Событие публикуется в Redis · доставляется обоим узлам · группы SignalR остаются локальным runtime-состоянием</a:t>
+            </a:r>
+          </a:p>
+        </p:txBody>
+      </p:sp>
+      <p:sp>
+        <p:nvSpPr>
+          <p:cNvPr id="27" name="Shape 27"/>
+          <p:cNvSpPr txBox="1"/>
+          <p:nvPr/>
+        </p:nvSpPr>
+        <p:spPr>
+          <a:xfrm>
+            <a:off x="640080" y="5440680"/>
+            <a:ext cx="10972800" cy="365760"/>
+          </a:xfrm>
+          <a:prstGeom prst="roundRect">
+            <a:avLst/>
+          </a:prstGeom>
+          <a:noFill/>
+          <a:ln>
+            <a:noFill/>
+          </a:ln>
+        </p:spPr>
+        <p:txBody>
+          <a:bodyPr wrap="square" lIns="177800" tIns="177800" rIns="177800" bIns="177800"/>
+          <a:lstStyle/>
+          <a:p>
+            <a:pPr algn="ctr"/>
+            <a:r>
+              <a:rPr lang="ru-RU" sz="1100" b="0">
+                <a:solidFill>
+                  <a:srgbClr val="5E6A75"/>
+                </a:solidFill>
+                <a:latin typeface="Aptos"/>
+                <a:cs typeface="Aptos"/>
+              </a:rPr>
+              <a:t>Оба экземпляра подключены к общей PostgreSQL; на схеме показан только канал real-time-доставки.</a:t>
             </a:r>
           </a:p>
         </p:txBody>
@@ -1325,7 +1818,44 @@
                 <a:latin typeface="Aptos"/>
                 <a:cs typeface="Aptos"/>
               </a:rPr>
-              <a:t>Стенд и программа испытаний</a:t>
+              <a:t>Что сделано</a:t>
+            </a:r>
+          </a:p>
+        </p:txBody>
+      </p:sp>
+      <p:sp>
+        <p:nvSpPr>
+          <p:cNvPr id="11" name="Shape 11"/>
+          <p:cNvSpPr txBox="1"/>
+          <p:nvPr/>
+        </p:nvSpPr>
+        <p:spPr>
+          <a:xfrm>
+            <a:off x="621792" y="987552"/>
+            <a:ext cx="9875520" cy="320040"/>
+          </a:xfrm>
+          <a:prstGeom prst="roundRect">
+            <a:avLst/>
+          </a:prstGeom>
+          <a:noFill/>
+          <a:ln>
+            <a:noFill/>
+          </a:ln>
+        </p:spPr>
+        <p:txBody>
+          <a:bodyPr wrap="square" lIns="177800" tIns="177800" rIns="177800" bIns="177800"/>
+          <a:lstStyle/>
+          <a:p>
+            <a:pPr algn="l"/>
+            <a:r>
+              <a:rPr lang="ru-RU" sz="1300" b="0">
+                <a:solidFill>
+                  <a:srgbClr val="5E6A75"/>
+                </a:solidFill>
+                <a:latin typeface="Aptos"/>
+                <a:cs typeface="Aptos"/>
+              </a:rPr>
+              <a:t>Backend-конфигурация, диагностика, стенд и проверочный клиент</a:t>
             </a:r>
           </a:p>
         </p:txBody>
@@ -1338,14 +1868,14 @@
         </p:nvSpPr>
         <p:spPr>
           <a:xfrm>
-            <a:off x="685800" y="1600200"/>
-            <a:ext cx="5212080" cy="2286000"/>
+            <a:off x="685800" y="1554480"/>
+            <a:ext cx="5349240" cy="2194560"/>
           </a:xfrm>
           <a:prstGeom prst="roundRect">
             <a:avLst/>
           </a:prstGeom>
           <a:solidFill>
-            <a:srgbClr val="E8F3F1"/>
+            <a:srgbClr val="FFFFFF"/>
           </a:solidFill>
           <a:ln w="12700">
             <a:solidFill>
@@ -1359,53 +1889,40 @@
           <a:p>
             <a:pPr algn="l"/>
             <a:r>
-              <a:rPr lang="ru-RU" sz="1500" b="0">
-                <a:solidFill>
-                  <a:srgbClr val="18212B"/>
-                </a:solidFill>
-                <a:latin typeface="Aptos"/>
-                <a:cs typeface="Aptos"/>
-              </a:rPr>
-              <a:t>Два режима</a:t>
-            </a:r>
-          </a:p>
-          <a:p>
-            <a:pPr algn="l"/>
-            <a:r>
-              <a:rPr lang="ru-RU" sz="1500" b="0">
-                <a:solidFill>
-                  <a:srgbClr val="18212B"/>
-                </a:solidFill>
-                <a:latin typeface="Aptos"/>
-                <a:cs typeface="Aptos"/>
-              </a:rPr>
-              <a:t>• С Redis backplane</a:t>
-            </a:r>
-          </a:p>
-          <a:p>
-            <a:pPr algn="l"/>
-            <a:r>
-              <a:rPr lang="ru-RU" sz="1500" b="0">
-                <a:solidFill>
-                  <a:srgbClr val="18212B"/>
-                </a:solidFill>
-                <a:latin typeface="Aptos"/>
-                <a:cs typeface="Aptos"/>
-              </a:rPr>
-              <a:t>• Без Redis backplane</a:t>
-            </a:r>
-          </a:p>
-          <a:p>
-            <a:pPr algn="l"/>
-            <a:r>
-              <a:rPr lang="ru-RU" sz="1500" b="0">
-                <a:solidFill>
-                  <a:srgbClr val="18212B"/>
-                </a:solidFill>
-                <a:latin typeface="Aptos"/>
-                <a:cs typeface="Aptos"/>
-              </a:rPr>
-              <a:t>Один и тот же код, разница — переменная окружения.</a:t>
+              <a:rPr lang="ru-RU" sz="1400" b="0">
+                <a:solidFill>
+                  <a:srgbClr val="18212B"/>
+                </a:solidFill>
+                <a:latin typeface="Aptos"/>
+                <a:cs typeface="Aptos"/>
+              </a:rPr>
+              <a:t>1 · Redis backplane для SignalR</a:t>
+            </a:r>
+          </a:p>
+          <a:p>
+            <a:pPr algn="l"/>
+            <a:r>
+              <a:rPr lang="ru-RU" sz="1400" b="0">
+                <a:solidFill>
+                  <a:srgbClr val="18212B"/>
+                </a:solidFill>
+                <a:latin typeface="Aptos"/>
+                <a:cs typeface="Aptos"/>
+              </a:rPr>
+              <a:t/>
+            </a:r>
+          </a:p>
+          <a:p>
+            <a:pPr algn="l"/>
+            <a:r>
+              <a:rPr lang="ru-RU" sz="1400" b="0">
+                <a:solidFill>
+                  <a:srgbClr val="18212B"/>
+                </a:solidFill>
+                <a:latin typeface="Aptos"/>
+                <a:cs typeface="Aptos"/>
+              </a:rPr>
+              <a:t>AddStackExchangeRedis с prefix app-api-realtime; включается переменной REDIS_CONNECTION_STRING — один и тот же код в обоих режимах.</a:t>
             </a:r>
           </a:p>
         </p:txBody>
@@ -1418,8 +1935,8 @@
         </p:nvSpPr>
         <p:spPr>
           <a:xfrm>
-            <a:off x="6172200" y="1600200"/>
-            <a:ext cx="5212080" cy="2286000"/>
+            <a:off x="685800" y="3840480"/>
+            <a:ext cx="5349240" cy="1874520"/>
           </a:xfrm>
           <a:prstGeom prst="roundRect">
             <a:avLst/>
@@ -1439,66 +1956,174 @@
           <a:p>
             <a:pPr algn="l"/>
             <a:r>
-              <a:rPr lang="ru-RU" sz="1500" b="0">
-                <a:solidFill>
-                  <a:srgbClr val="18212B"/>
-                </a:solidFill>
-                <a:latin typeface="Aptos"/>
-                <a:cs typeface="Aptos"/>
-              </a:rPr>
-              <a:t>Четыре сценария</a:t>
-            </a:r>
-          </a:p>
-          <a:p>
-            <a:pPr algn="l"/>
-            <a:r>
-              <a:rPr lang="ru-RU" sz="1500" b="0">
-                <a:solidFill>
-                  <a:srgbClr val="18212B"/>
-                </a:solidFill>
-                <a:latin typeface="Aptos"/>
-                <a:cs typeface="Aptos"/>
-              </a:rPr>
-              <a:t>• Одиночная доставка</a:t>
-            </a:r>
-          </a:p>
-          <a:p>
-            <a:pPr algn="l"/>
-            <a:r>
-              <a:rPr lang="ru-RU" sz="1500" b="0">
-                <a:solidFill>
-                  <a:srgbClr val="18212B"/>
-                </a:solidFill>
-                <a:latin typeface="Aptos"/>
-                <a:cs typeface="Aptos"/>
-              </a:rPr>
-              <a:t>• Серия из 5 итераций</a:t>
-            </a:r>
-          </a:p>
-          <a:p>
-            <a:pPr algn="l"/>
-            <a:r>
-              <a:rPr lang="ru-RU" sz="1500" b="0">
-                <a:solidFill>
-                  <a:srgbClr val="18212B"/>
-                </a:solidFill>
-                <a:latin typeface="Aptos"/>
-                <a:cs typeface="Aptos"/>
-              </a:rPr>
-              <a:t>• Rejoin после разрыва</a:t>
-            </a:r>
-          </a:p>
-          <a:p>
-            <a:pPr algn="l"/>
-            <a:r>
-              <a:rPr lang="ru-RU" sz="1500" b="0">
-                <a:solidFill>
-                  <a:srgbClr val="18212B"/>
-                </a:solidFill>
-                <a:latin typeface="Aptos"/>
-                <a:cs typeface="Aptos"/>
-              </a:rPr>
-              <a:t>• Failover узла</a:t>
+              <a:rPr lang="ru-RU" sz="1400" b="0">
+                <a:solidFill>
+                  <a:srgbClr val="18212B"/>
+                </a:solidFill>
+                <a:latin typeface="Aptos"/>
+                <a:cs typeface="Aptos"/>
+              </a:rPr>
+              <a:t>2 · Диагностический контур</a:t>
+            </a:r>
+          </a:p>
+          <a:p>
+            <a:pPr algn="l"/>
+            <a:r>
+              <a:rPr lang="ru-RU" sz="1400" b="0">
+                <a:solidFill>
+                  <a:srgbClr val="18212B"/>
+                </a:solidFill>
+                <a:latin typeface="Aptos"/>
+                <a:cs typeface="Aptos"/>
+              </a:rPr>
+              <a:t/>
+            </a:r>
+          </a:p>
+          <a:p>
+            <a:pPr algn="l"/>
+            <a:r>
+              <a:rPr lang="ru-RU" sz="1400" b="0">
+                <a:solidFill>
+                  <a:srgbClr val="18212B"/>
+                </a:solidFill>
+                <a:latin typeface="Aptos"/>
+                <a:cs typeface="Aptos"/>
+              </a:rPr>
+              <a:t>SERVER_INSTANCE_ID, GetConnectionDiagnosticsAsync(), логирование подключения, вступления в группу и отправки события.</a:t>
+            </a:r>
+          </a:p>
+        </p:txBody>
+      </p:sp>
+      <p:sp>
+        <p:nvSpPr>
+          <p:cNvPr id="22" name="Shape 22"/>
+          <p:cNvSpPr txBox="1"/>
+          <p:nvPr/>
+        </p:nvSpPr>
+        <p:spPr>
+          <a:xfrm>
+            <a:off x="6172200" y="1554480"/>
+            <a:ext cx="5349240" cy="2194560"/>
+          </a:xfrm>
+          <a:prstGeom prst="roundRect">
+            <a:avLst/>
+          </a:prstGeom>
+          <a:solidFill>
+            <a:srgbClr val="FFFFFF"/>
+          </a:solidFill>
+          <a:ln w="12700">
+            <a:solidFill>
+              <a:srgbClr val="D7D2C7"/>
+            </a:solidFill>
+          </a:ln>
+        </p:spPr>
+        <p:txBody>
+          <a:bodyPr wrap="square" lIns="177800" tIns="177800" rIns="177800" bIns="177800"/>
+          <a:lstStyle/>
+          <a:p>
+            <a:pPr algn="l"/>
+            <a:r>
+              <a:rPr lang="ru-RU" sz="1400" b="0">
+                <a:solidFill>
+                  <a:srgbClr val="18212B"/>
+                </a:solidFill>
+                <a:latin typeface="Aptos"/>
+                <a:cs typeface="Aptos"/>
+              </a:rPr>
+              <a:t>3 · Multi-instance стенд</a:t>
+            </a:r>
+          </a:p>
+          <a:p>
+            <a:pPr algn="l"/>
+            <a:r>
+              <a:rPr lang="ru-RU" sz="1400" b="0">
+                <a:solidFill>
+                  <a:srgbClr val="18212B"/>
+                </a:solidFill>
+                <a:latin typeface="Aptos"/>
+                <a:cs typeface="Aptos"/>
+              </a:rPr>
+              <a:t/>
+            </a:r>
+          </a:p>
+          <a:p>
+            <a:pPr algn="l"/>
+            <a:r>
+              <a:rPr lang="ru-RU" sz="1400" b="0">
+                <a:solidFill>
+                  <a:srgbClr val="18212B"/>
+                </a:solidFill>
+                <a:latin typeface="Aptos"/>
+                <a:cs typeface="Aptos"/>
+              </a:rPr>
+              <a:t>docker-compose.thesis.yml: app-api-1, app-api-2, Redis, PostgreSQL, nginx; override .no-backplane.yml для воспроизведения исходной проблемы.</a:t>
+            </a:r>
+          </a:p>
+        </p:txBody>
+      </p:sp>
+      <p:sp>
+        <p:nvSpPr>
+          <p:cNvPr id="23" name="Shape 23"/>
+          <p:cNvSpPr txBox="1"/>
+          <p:nvPr/>
+        </p:nvSpPr>
+        <p:spPr>
+          <a:xfrm>
+            <a:off x="6172200" y="3840480"/>
+            <a:ext cx="5349240" cy="1874520"/>
+          </a:xfrm>
+          <a:prstGeom prst="roundRect">
+            <a:avLst/>
+          </a:prstGeom>
+          <a:solidFill>
+            <a:srgbClr val="FFFFFF"/>
+          </a:solidFill>
+          <a:ln w="12700">
+            <a:solidFill>
+              <a:srgbClr val="D7D2C7"/>
+            </a:solidFill>
+          </a:ln>
+        </p:spPr>
+        <p:txBody>
+          <a:bodyPr wrap="square" lIns="177800" tIns="177800" rIns="177800" bIns="177800"/>
+          <a:lstStyle/>
+          <a:p>
+            <a:pPr algn="l"/>
+            <a:r>
+              <a:rPr lang="ru-RU" sz="1400" b="0">
+                <a:solidFill>
+                  <a:srgbClr val="18212B"/>
+                </a:solidFill>
+                <a:latin typeface="Aptos"/>
+                <a:cs typeface="Aptos"/>
+              </a:rPr>
+              <a:t>4 · Проверочный клиент на Node.js</a:t>
+            </a:r>
+          </a:p>
+          <a:p>
+            <a:pPr algn="l"/>
+            <a:r>
+              <a:rPr lang="ru-RU" sz="1400" b="0">
+                <a:solidFill>
+                  <a:srgbClr val="18212B"/>
+                </a:solidFill>
+                <a:latin typeface="Aptos"/>
+                <a:cs typeface="Aptos"/>
+              </a:rPr>
+              <a:t/>
+            </a:r>
+          </a:p>
+          <a:p>
+            <a:pPr algn="l"/>
+            <a:r>
+              <a:rPr lang="ru-RU" sz="1400" b="0">
+                <a:solidFill>
+                  <a:srgbClr val="18212B"/>
+                </a:solidFill>
+                <a:latin typeface="Aptos"/>
+                <a:cs typeface="Aptos"/>
+              </a:rPr>
+              <a:t>realtime-scaleout-check.mjs: одиночная доставка, серия, rejoin, failover.</a:t>
             </a:r>
           </a:p>
         </p:txBody>
@@ -1605,7 +2230,44 @@
                 <a:latin typeface="Aptos"/>
                 <a:cs typeface="Aptos"/>
               </a:rPr>
-              <a:t>Главный результат</a:t>
+              <a:t>Программа испытаний</a:t>
+            </a:r>
+          </a:p>
+        </p:txBody>
+      </p:sp>
+      <p:sp>
+        <p:nvSpPr>
+          <p:cNvPr id="11" name="Shape 11"/>
+          <p:cNvSpPr txBox="1"/>
+          <p:nvPr/>
+        </p:nvSpPr>
+        <p:spPr>
+          <a:xfrm>
+            <a:off x="621792" y="987552"/>
+            <a:ext cx="9875520" cy="320040"/>
+          </a:xfrm>
+          <a:prstGeom prst="roundRect">
+            <a:avLst/>
+          </a:prstGeom>
+          <a:noFill/>
+          <a:ln>
+            <a:noFill/>
+          </a:ln>
+        </p:spPr>
+        <p:txBody>
+          <a:bodyPr wrap="square" lIns="177800" tIns="177800" rIns="177800" bIns="177800"/>
+          <a:lstStyle/>
+          <a:p>
+            <a:pPr algn="l"/>
+            <a:r>
+              <a:rPr lang="ru-RU" sz="1300" b="0">
+                <a:solidFill>
+                  <a:srgbClr val="5E6A75"/>
+                </a:solidFill>
+                <a:latin typeface="Aptos"/>
+                <a:cs typeface="Aptos"/>
+              </a:rPr>
+              <a:t>Два режима по одному коду · четыре сценария проверки</a:t>
             </a:r>
           </a:p>
         </p:txBody>
@@ -1619,74 +2281,7 @@
         <p:spPr>
           <a:xfrm>
             <a:off x="685800" y="1554480"/>
-            <a:ext cx="5212080" cy="2377440"/>
-          </a:xfrm>
-          <a:prstGeom prst="roundRect">
-            <a:avLst/>
-          </a:prstGeom>
-          <a:solidFill>
-            <a:srgbClr val="FFF3D8"/>
-          </a:solidFill>
-          <a:ln w="12700">
-            <a:solidFill>
-              <a:srgbClr val="C76F2E"/>
-            </a:solidFill>
-          </a:ln>
-        </p:spPr>
-        <p:txBody>
-          <a:bodyPr wrap="square" lIns="177800" tIns="177800" rIns="177800" bIns="177800"/>
-          <a:lstStyle/>
-          <a:p>
-            <a:pPr algn="ctr"/>
-            <a:r>
-              <a:rPr lang="ru-RU" sz="2000" b="1">
-                <a:solidFill>
-                  <a:srgbClr val="18212B"/>
-                </a:solidFill>
-                <a:latin typeface="Aptos"/>
-                <a:cs typeface="Aptos"/>
-              </a:rPr>
-              <a:t>Без backplane</a:t>
-            </a:r>
-          </a:p>
-          <a:p>
-            <a:pPr algn="ctr"/>
-            <a:r>
-              <a:rPr lang="ru-RU" sz="2000" b="1">
-                <a:solidFill>
-                  <a:srgbClr val="18212B"/>
-                </a:solidFill>
-                <a:latin typeface="Aptos"/>
-                <a:cs typeface="Aptos"/>
-              </a:rPr>
-              <a:t>timeout 10000 мс</a:t>
-            </a:r>
-          </a:p>
-          <a:p>
-            <a:pPr algn="ctr"/>
-            <a:r>
-              <a:rPr lang="ru-RU" sz="2000" b="1">
-                <a:solidFill>
-                  <a:srgbClr val="18212B"/>
-                </a:solidFill>
-                <a:latin typeface="Aptos"/>
-                <a:cs typeface="Aptos"/>
-              </a:rPr>
-              <a:t>событие не доставлено</a:t>
-            </a:r>
-          </a:p>
-        </p:txBody>
-      </p:sp>
-      <p:sp>
-        <p:nvSpPr>
-          <p:cNvPr id="21" name="Shape 21"/>
-          <p:cNvSpPr txBox="1"/>
-          <p:nvPr/>
-        </p:nvSpPr>
-        <p:spPr>
-          <a:xfrm>
-            <a:off x="6172200" y="1554480"/>
-            <a:ext cx="5212080" cy="2377440"/>
+            <a:ext cx="5349240" cy="4160520"/>
           </a:xfrm>
           <a:prstGeom prst="roundRect">
             <a:avLst/>
@@ -1704,79 +2299,239 @@
           <a:bodyPr wrap="square" lIns="177800" tIns="177800" rIns="177800" bIns="177800"/>
           <a:lstStyle/>
           <a:p>
-            <a:pPr algn="ctr"/>
-            <a:r>
-              <a:rPr lang="ru-RU" sz="2000" b="1">
-                <a:solidFill>
-                  <a:srgbClr val="18212B"/>
-                </a:solidFill>
-                <a:latin typeface="Aptos"/>
-                <a:cs typeface="Aptos"/>
-              </a:rPr>
-              <a:t>С backplane</a:t>
-            </a:r>
-          </a:p>
-          <a:p>
-            <a:pPr algn="ctr"/>
-            <a:r>
-              <a:rPr lang="ru-RU" sz="2000" b="1">
-                <a:solidFill>
-                  <a:srgbClr val="18212B"/>
-                </a:solidFill>
-                <a:latin typeface="Aptos"/>
-                <a:cs typeface="Aptos"/>
-              </a:rPr>
-              <a:t>ok: true · 5 из 5</a:t>
-            </a:r>
-          </a:p>
-          <a:p>
-            <a:pPr algn="ctr"/>
-            <a:r>
-              <a:rPr lang="ru-RU" sz="2000" b="1">
-                <a:solidFill>
-                  <a:srgbClr val="18212B"/>
-                </a:solidFill>
-                <a:latin typeface="Aptos"/>
-                <a:cs typeface="Aptos"/>
-              </a:rPr>
-              <a:t>p95 = 11,6 мс</a:t>
-            </a:r>
-          </a:p>
-        </p:txBody>
-      </p:sp>
-      <p:sp>
-        <p:nvSpPr>
-          <p:cNvPr id="22" name="Shape 22"/>
-          <p:cNvSpPr txBox="1"/>
-          <p:nvPr/>
-        </p:nvSpPr>
-        <p:spPr>
-          <a:xfrm>
-            <a:off x="685800" y="4297680"/>
-            <a:ext cx="10698480" cy="502920"/>
-          </a:xfrm>
-          <a:prstGeom prst="roundRect">
-            <a:avLst/>
-          </a:prstGeom>
-          <a:noFill/>
-          <a:ln>
-            <a:noFill/>
-          </a:ln>
-        </p:spPr>
-        <p:txBody>
-          <a:bodyPr wrap="square" lIns="177800" tIns="177800" rIns="177800" bIns="177800"/>
-          <a:lstStyle/>
-          <a:p>
-            <a:pPr algn="ctr"/>
-            <a:r>
-              <a:rPr lang="ru-RU" sz="1400" b="0">
-                <a:solidFill>
-                  <a:srgbClr val="5E6A75"/>
-                </a:solidFill>
-                <a:latin typeface="Aptos"/>
-                <a:cs typeface="Aptos"/>
-              </a:rPr>
-              <a:t>Один код, один сценарий — разница только в наличии межузлового канала.</a:t>
+            <a:pPr algn="l"/>
+            <a:r>
+              <a:rPr lang="ru-RU" sz="1500" b="1">
+                <a:solidFill>
+                  <a:srgbClr val="18212B"/>
+                </a:solidFill>
+                <a:latin typeface="Aptos"/>
+                <a:cs typeface="Aptos"/>
+              </a:rPr>
+              <a:t>Два режима</a:t>
+            </a:r>
+          </a:p>
+          <a:p>
+            <a:pPr algn="l"/>
+            <a:r>
+              <a:rPr lang="ru-RU" sz="1500" b="1">
+                <a:solidFill>
+                  <a:srgbClr val="18212B"/>
+                </a:solidFill>
+                <a:latin typeface="Aptos"/>
+                <a:cs typeface="Aptos"/>
+              </a:rPr>
+              <a:t/>
+            </a:r>
+          </a:p>
+          <a:p>
+            <a:pPr algn="l"/>
+            <a:r>
+              <a:rPr lang="ru-RU" sz="1500" b="1">
+                <a:solidFill>
+                  <a:srgbClr val="18212B"/>
+                </a:solidFill>
+                <a:latin typeface="Aptos"/>
+                <a:cs typeface="Aptos"/>
+              </a:rPr>
+              <a:t>• Multi-instance без Redis backplane — воспроизведение проблемы</a:t>
+            </a:r>
+          </a:p>
+          <a:p>
+            <a:pPr algn="l"/>
+            <a:r>
+              <a:rPr lang="ru-RU" sz="1500" b="1">
+                <a:solidFill>
+                  <a:srgbClr val="18212B"/>
+                </a:solidFill>
+                <a:latin typeface="Aptos"/>
+                <a:cs typeface="Aptos"/>
+              </a:rPr>
+              <a:t/>
+            </a:r>
+          </a:p>
+          <a:p>
+            <a:pPr algn="l"/>
+            <a:r>
+              <a:rPr lang="ru-RU" sz="1500" b="1">
+                <a:solidFill>
+                  <a:srgbClr val="18212B"/>
+                </a:solidFill>
+                <a:latin typeface="Aptos"/>
+                <a:cs typeface="Aptos"/>
+              </a:rPr>
+              <a:t>• Multi-instance с Redis backplane — проверка решения</a:t>
+            </a:r>
+          </a:p>
+          <a:p>
+            <a:pPr algn="l"/>
+            <a:r>
+              <a:rPr lang="ru-RU" sz="1500" b="1">
+                <a:solidFill>
+                  <a:srgbClr val="18212B"/>
+                </a:solidFill>
+                <a:latin typeface="Aptos"/>
+                <a:cs typeface="Aptos"/>
+              </a:rPr>
+              <a:t/>
+            </a:r>
+          </a:p>
+          <a:p>
+            <a:pPr algn="l"/>
+            <a:r>
+              <a:rPr lang="ru-RU" sz="1500" b="1">
+                <a:solidFill>
+                  <a:srgbClr val="18212B"/>
+                </a:solidFill>
+                <a:latin typeface="Aptos"/>
+                <a:cs typeface="Aptos"/>
+              </a:rPr>
+              <a:t>Один и тот же код, один и тот же сценарий; отличие — значение REDIS_CONNECTION_STRING.</a:t>
+            </a:r>
+          </a:p>
+        </p:txBody>
+      </p:sp>
+      <p:sp>
+        <p:nvSpPr>
+          <p:cNvPr id="21" name="Shape 21"/>
+          <p:cNvSpPr txBox="1"/>
+          <p:nvPr/>
+        </p:nvSpPr>
+        <p:spPr>
+          <a:xfrm>
+            <a:off x="6172200" y="1554480"/>
+            <a:ext cx="5349240" cy="4160520"/>
+          </a:xfrm>
+          <a:prstGeom prst="roundRect">
+            <a:avLst/>
+          </a:prstGeom>
+          <a:solidFill>
+            <a:srgbClr val="FFFFFF"/>
+          </a:solidFill>
+          <a:ln w="12700">
+            <a:solidFill>
+              <a:srgbClr val="D7D2C7"/>
+            </a:solidFill>
+          </a:ln>
+        </p:spPr>
+        <p:txBody>
+          <a:bodyPr wrap="square" lIns="177800" tIns="177800" rIns="177800" bIns="177800"/>
+          <a:lstStyle/>
+          <a:p>
+            <a:pPr algn="l"/>
+            <a:r>
+              <a:rPr lang="ru-RU" sz="1500" b="0">
+                <a:solidFill>
+                  <a:srgbClr val="18212B"/>
+                </a:solidFill>
+                <a:latin typeface="Aptos"/>
+                <a:cs typeface="Aptos"/>
+              </a:rPr>
+              <a:t>Четыре сценария</a:t>
+            </a:r>
+          </a:p>
+          <a:p>
+            <a:pPr algn="l"/>
+            <a:r>
+              <a:rPr lang="ru-RU" sz="1500" b="0">
+                <a:solidFill>
+                  <a:srgbClr val="18212B"/>
+                </a:solidFill>
+                <a:latin typeface="Aptos"/>
+                <a:cs typeface="Aptos"/>
+              </a:rPr>
+              <a:t/>
+            </a:r>
+          </a:p>
+          <a:p>
+            <a:pPr algn="l"/>
+            <a:r>
+              <a:rPr lang="ru-RU" sz="1500" b="0">
+                <a:solidFill>
+                  <a:srgbClr val="18212B"/>
+                </a:solidFill>
+                <a:latin typeface="Aptos"/>
+                <a:cs typeface="Aptos"/>
+              </a:rPr>
+              <a:t>• Одиночная cross-node доставка</a:t>
+            </a:r>
+          </a:p>
+          <a:p>
+            <a:pPr algn="l"/>
+            <a:r>
+              <a:rPr lang="ru-RU" sz="1500" b="0">
+                <a:solidFill>
+                  <a:srgbClr val="18212B"/>
+                </a:solidFill>
+                <a:latin typeface="Aptos"/>
+                <a:cs typeface="Aptos"/>
+              </a:rPr>
+              <a:t/>
+            </a:r>
+          </a:p>
+          <a:p>
+            <a:pPr algn="l"/>
+            <a:r>
+              <a:rPr lang="ru-RU" sz="1500" b="0">
+                <a:solidFill>
+                  <a:srgbClr val="18212B"/>
+                </a:solidFill>
+                <a:latin typeface="Aptos"/>
+                <a:cs typeface="Aptos"/>
+              </a:rPr>
+              <a:t>• Серия из 5 итераций (THESIS_ITERATIONS)</a:t>
+            </a:r>
+          </a:p>
+          <a:p>
+            <a:pPr algn="l"/>
+            <a:r>
+              <a:rPr lang="ru-RU" sz="1500" b="0">
+                <a:solidFill>
+                  <a:srgbClr val="18212B"/>
+                </a:solidFill>
+                <a:latin typeface="Aptos"/>
+                <a:cs typeface="Aptos"/>
+              </a:rPr>
+              <a:t/>
+            </a:r>
+          </a:p>
+          <a:p>
+            <a:pPr algn="l"/>
+            <a:r>
+              <a:rPr lang="ru-RU" sz="1500" b="0">
+                <a:solidFill>
+                  <a:srgbClr val="18212B"/>
+                </a:solidFill>
+                <a:latin typeface="Aptos"/>
+                <a:cs typeface="Aptos"/>
+              </a:rPr>
+              <a:t>• Rejoin после разрыва соединения</a:t>
+            </a:r>
+          </a:p>
+          <a:p>
+            <a:pPr algn="l"/>
+            <a:r>
+              <a:rPr lang="ru-RU" sz="1500" b="0">
+                <a:solidFill>
+                  <a:srgbClr val="18212B"/>
+                </a:solidFill>
+                <a:latin typeface="Aptos"/>
+                <a:cs typeface="Aptos"/>
+              </a:rPr>
+              <a:t/>
+            </a:r>
+          </a:p>
+          <a:p>
+            <a:pPr algn="l"/>
+            <a:r>
+              <a:rPr lang="ru-RU" sz="1500" b="0">
+                <a:solidFill>
+                  <a:srgbClr val="18212B"/>
+                </a:solidFill>
+                <a:latin typeface="Aptos"/>
+                <a:cs typeface="Aptos"/>
+              </a:rPr>
+              <a:t>• Failover после остановки узла</a:t>
             </a:r>
           </a:p>
         </p:txBody>
@@ -1883,7 +2638,44 @@
                 <a:latin typeface="Aptos"/>
                 <a:cs typeface="Aptos"/>
               </a:rPr>
-              <a:t>Устойчивость: rejoin и failover</a:t>
+              <a:t>Главный результат</a:t>
+            </a:r>
+          </a:p>
+        </p:txBody>
+      </p:sp>
+      <p:sp>
+        <p:nvSpPr>
+          <p:cNvPr id="11" name="Shape 11"/>
+          <p:cNvSpPr txBox="1"/>
+          <p:nvPr/>
+        </p:nvSpPr>
+        <p:spPr>
+          <a:xfrm>
+            <a:off x="621792" y="987552"/>
+            <a:ext cx="9875520" cy="320040"/>
+          </a:xfrm>
+          <a:prstGeom prst="roundRect">
+            <a:avLst/>
+          </a:prstGeom>
+          <a:noFill/>
+          <a:ln>
+            <a:noFill/>
+          </a:ln>
+        </p:spPr>
+        <p:txBody>
+          <a:bodyPr wrap="square" lIns="177800" tIns="177800" rIns="177800" bIns="177800"/>
+          <a:lstStyle/>
+          <a:p>
+            <a:pPr algn="l"/>
+            <a:r>
+              <a:rPr lang="ru-RU" sz="1300" b="0">
+                <a:solidFill>
+                  <a:srgbClr val="5E6A75"/>
+                </a:solidFill>
+                <a:latin typeface="Aptos"/>
+                <a:cs typeface="Aptos"/>
+              </a:rPr>
+              <a:t>Один код и один сценарий — разница только в наличии Redis-канала</a:t>
             </a:r>
           </a:p>
         </p:txBody>
@@ -1896,18 +2688,18 @@
         </p:nvSpPr>
         <p:spPr>
           <a:xfrm>
-            <a:off x="685800" y="1600200"/>
-            <a:ext cx="5212080" cy="2286000"/>
+            <a:off x="685800" y="1554480"/>
+            <a:ext cx="5349240" cy="3291840"/>
           </a:xfrm>
           <a:prstGeom prst="roundRect">
             <a:avLst/>
           </a:prstGeom>
           <a:solidFill>
-            <a:srgbClr val="FFFFFF"/>
+            <a:srgbClr val="FFF3D8"/>
           </a:solidFill>
           <a:ln w="12700">
             <a:solidFill>
-              <a:srgbClr val="D7D2C7"/>
+              <a:srgbClr val="C76F2E"/>
             </a:solidFill>
           </a:ln>
         </p:spPr>
@@ -1915,42 +2707,81 @@
           <a:bodyPr wrap="square" lIns="177800" tIns="177800" rIns="177800" bIns="177800"/>
           <a:lstStyle/>
           <a:p>
-            <a:pPr algn="l"/>
-            <a:r>
-              <a:rPr lang="ru-RU" sz="1500" b="0">
-                <a:solidFill>
-                  <a:srgbClr val="18212B"/>
-                </a:solidFill>
-                <a:latin typeface="Aptos"/>
-                <a:cs typeface="Aptos"/>
-              </a:rPr>
-              <a:t>Rejoin после разрыва</a:t>
-            </a:r>
-          </a:p>
-          <a:p>
-            <a:pPr algn="l"/>
-            <a:r>
-              <a:rPr lang="ru-RU" sz="1500" b="0">
-                <a:solidFill>
-                  <a:srgbClr val="18212B"/>
-                </a:solidFill>
-                <a:latin typeface="Aptos"/>
-                <a:cs typeface="Aptos"/>
-              </a:rPr>
-              <a:t>Новый connectionId, повторный JoinReportGroupAsync.</a:t>
-            </a:r>
-          </a:p>
-          <a:p>
-            <a:pPr algn="l"/>
-            <a:r>
-              <a:rPr lang="ru-RU" sz="1500" b="0">
-                <a:solidFill>
-                  <a:srgbClr val="18212B"/>
-                </a:solidFill>
-                <a:latin typeface="Aptos"/>
-                <a:cs typeface="Aptos"/>
-              </a:rPr>
-              <a:t>Событие после rejoin — 6,6 мс.</a:t>
+            <a:pPr algn="ctr"/>
+            <a:r>
+              <a:rPr lang="ru-RU" sz="1800" b="1">
+                <a:solidFill>
+                  <a:srgbClr val="18212B"/>
+                </a:solidFill>
+                <a:latin typeface="Aptos"/>
+                <a:cs typeface="Aptos"/>
+              </a:rPr>
+              <a:t>Без backplane</a:t>
+            </a:r>
+          </a:p>
+          <a:p>
+            <a:pPr algn="ctr"/>
+            <a:r>
+              <a:rPr lang="ru-RU" sz="1800" b="1">
+                <a:solidFill>
+                  <a:srgbClr val="18212B"/>
+                </a:solidFill>
+                <a:latin typeface="Aptos"/>
+                <a:cs typeface="Aptos"/>
+              </a:rPr>
+              <a:t/>
+            </a:r>
+          </a:p>
+          <a:p>
+            <a:pPr algn="ctr"/>
+            <a:r>
+              <a:rPr lang="ru-RU" sz="1800" b="1">
+                <a:solidFill>
+                  <a:srgbClr val="18212B"/>
+                </a:solidFill>
+                <a:latin typeface="Aptos"/>
+                <a:cs typeface="Aptos"/>
+              </a:rPr>
+              <a:t>ReceiveReportPatch</a:t>
+            </a:r>
+          </a:p>
+          <a:p>
+            <a:pPr algn="ctr"/>
+            <a:r>
+              <a:rPr lang="ru-RU" sz="1800" b="1">
+                <a:solidFill>
+                  <a:srgbClr val="18212B"/>
+                </a:solidFill>
+                <a:latin typeface="Aptos"/>
+                <a:cs typeface="Aptos"/>
+              </a:rPr>
+              <a:t>timed out · 10 000 мс</a:t>
+            </a:r>
+          </a:p>
+          <a:p>
+            <a:pPr algn="ctr"/>
+            <a:r>
+              <a:rPr lang="ru-RU" sz="1800" b="1">
+                <a:solidFill>
+                  <a:srgbClr val="18212B"/>
+                </a:solidFill>
+                <a:latin typeface="Aptos"/>
+                <a:cs typeface="Aptos"/>
+              </a:rPr>
+              <a:t/>
+            </a:r>
+          </a:p>
+          <a:p>
+            <a:pPr algn="ctr"/>
+            <a:r>
+              <a:rPr lang="ru-RU" sz="1800" b="1">
+                <a:solidFill>
+                  <a:srgbClr val="18212B"/>
+                </a:solidFill>
+                <a:latin typeface="Aptos"/>
+                <a:cs typeface="Aptos"/>
+              </a:rPr>
+              <a:t>Событие, созданное на app-api-1, не дошло до клиента на app-api-2</a:t>
             </a:r>
           </a:p>
         </p:txBody>
@@ -1963,8 +2794,8 @@
         </p:nvSpPr>
         <p:spPr>
           <a:xfrm>
-            <a:off x="6172200" y="1600200"/>
-            <a:ext cx="5212080" cy="2286000"/>
+            <a:off x="6172200" y="1554480"/>
+            <a:ext cx="5349240" cy="3291840"/>
           </a:xfrm>
           <a:prstGeom prst="roundRect">
             <a:avLst/>
@@ -1982,42 +2813,118 @@
           <a:bodyPr wrap="square" lIns="177800" tIns="177800" rIns="177800" bIns="177800"/>
           <a:lstStyle/>
           <a:p>
-            <a:pPr algn="l"/>
-            <a:r>
-              <a:rPr lang="ru-RU" sz="1500" b="0">
-                <a:solidFill>
-                  <a:srgbClr val="18212B"/>
-                </a:solidFill>
-                <a:latin typeface="Aptos"/>
-                <a:cs typeface="Aptos"/>
-              </a:rPr>
-              <a:t>Failover узла</a:t>
-            </a:r>
-          </a:p>
-          <a:p>
-            <a:pPr algn="l"/>
-            <a:r>
-              <a:rPr lang="ru-RU" sz="1500" b="0">
-                <a:solidFill>
-                  <a:srgbClr val="18212B"/>
-                </a:solidFill>
-                <a:latin typeface="Aptos"/>
-                <a:cs typeface="Aptos"/>
-              </a:rPr>
-              <a:t>Клиент переподключился через nginx с app-api-2 на app-api-1.</a:t>
-            </a:r>
-          </a:p>
-          <a:p>
-            <a:pPr algn="l"/>
-            <a:r>
-              <a:rPr lang="ru-RU" sz="1500" b="0">
-                <a:solidFill>
-                  <a:srgbClr val="18212B"/>
-                </a:solidFill>
-                <a:latin typeface="Aptos"/>
-                <a:cs typeface="Aptos"/>
-              </a:rPr>
-              <a:t>reconnect + rejoin — 240,3 мс.</a:t>
+            <a:pPr algn="ctr"/>
+            <a:r>
+              <a:rPr lang="ru-RU" sz="1800" b="1">
+                <a:solidFill>
+                  <a:srgbClr val="18212B"/>
+                </a:solidFill>
+                <a:latin typeface="Aptos"/>
+                <a:cs typeface="Aptos"/>
+              </a:rPr>
+              <a:t>С backplane</a:t>
+            </a:r>
+          </a:p>
+          <a:p>
+            <a:pPr algn="ctr"/>
+            <a:r>
+              <a:rPr lang="ru-RU" sz="1800" b="1">
+                <a:solidFill>
+                  <a:srgbClr val="18212B"/>
+                </a:solidFill>
+                <a:latin typeface="Aptos"/>
+                <a:cs typeface="Aptos"/>
+              </a:rPr>
+              <a:t/>
+            </a:r>
+          </a:p>
+          <a:p>
+            <a:pPr algn="ctr"/>
+            <a:r>
+              <a:rPr lang="ru-RU" sz="1800" b="1">
+                <a:solidFill>
+                  <a:srgbClr val="18212B"/>
+                </a:solidFill>
+                <a:latin typeface="Aptos"/>
+                <a:cs typeface="Aptos"/>
+              </a:rPr>
+              <a:t>ok: true · ReceiveReportPatch получен</a:t>
+            </a:r>
+          </a:p>
+          <a:p>
+            <a:pPr algn="ctr"/>
+            <a:r>
+              <a:rPr lang="ru-RU" sz="1800" b="1">
+                <a:solidFill>
+                  <a:srgbClr val="18212B"/>
+                </a:solidFill>
+                <a:latin typeface="Aptos"/>
+                <a:cs typeface="Aptos"/>
+              </a:rPr>
+              <a:t>deliveryLatencyMs ≈ 9,5 мс</a:t>
+            </a:r>
+          </a:p>
+          <a:p>
+            <a:pPr algn="ctr"/>
+            <a:r>
+              <a:rPr lang="ru-RU" sz="1800" b="1">
+                <a:solidFill>
+                  <a:srgbClr val="18212B"/>
+                </a:solidFill>
+                <a:latin typeface="Aptos"/>
+                <a:cs typeface="Aptos"/>
+              </a:rPr>
+              <a:t/>
+            </a:r>
+          </a:p>
+          <a:p>
+            <a:pPr algn="ctr"/>
+            <a:r>
+              <a:rPr lang="ru-RU" sz="1800" b="1">
+                <a:solidFill>
+                  <a:srgbClr val="18212B"/>
+                </a:solidFill>
+                <a:latin typeface="Aptos"/>
+                <a:cs typeface="Aptos"/>
+              </a:rPr>
+              <a:t>Клиент на app-api-2 получил событие с app-api-1</a:t>
+            </a:r>
+          </a:p>
+        </p:txBody>
+      </p:sp>
+      <p:sp>
+        <p:nvSpPr>
+          <p:cNvPr id="22" name="Shape 22"/>
+          <p:cNvSpPr txBox="1"/>
+          <p:nvPr/>
+        </p:nvSpPr>
+        <p:spPr>
+          <a:xfrm>
+            <a:off x="685800" y="5074920"/>
+            <a:ext cx="10835640" cy="777240"/>
+          </a:xfrm>
+          <a:prstGeom prst="roundRect">
+            <a:avLst/>
+          </a:prstGeom>
+          <a:noFill/>
+          <a:ln>
+            <a:noFill/>
+          </a:ln>
+        </p:spPr>
+        <p:txBody>
+          <a:bodyPr wrap="square" lIns="177800" tIns="177800" rIns="177800" bIns="177800"/>
+          <a:lstStyle/>
+          <a:p>
+            <a:pPr algn="ctr"/>
+            <a:r>
+              <a:rPr lang="ru-RU" sz="1300" b="0">
+                <a:solidFill>
+                  <a:srgbClr val="5E6A75"/>
+                </a:solidFill>
+                <a:latin typeface="Aptos"/>
+                <a:cs typeface="Aptos"/>
+              </a:rPr>
+              <a:t>Сопоставление двух режимов на одном стенде показывает причинную связь между включением межузлового канала SignalR и успешной доставкой события.</a:t>
             </a:r>
           </a:p>
         </p:txBody>
@@ -2124,7 +3031,44 @@
                 <a:latin typeface="Aptos"/>
                 <a:cs typeface="Aptos"/>
               </a:rPr>
-              <a:t>Вывод</a:t>
+              <a:t>Дополнительные проверки</a:t>
+            </a:r>
+          </a:p>
+        </p:txBody>
+      </p:sp>
+      <p:sp>
+        <p:nvSpPr>
+          <p:cNvPr id="11" name="Shape 11"/>
+          <p:cNvSpPr txBox="1"/>
+          <p:nvPr/>
+        </p:nvSpPr>
+        <p:spPr>
+          <a:xfrm>
+            <a:off x="621792" y="987552"/>
+            <a:ext cx="9875520" cy="320040"/>
+          </a:xfrm>
+          <a:prstGeom prst="roundRect">
+            <a:avLst/>
+          </a:prstGeom>
+          <a:noFill/>
+          <a:ln>
+            <a:noFill/>
+          </a:ln>
+        </p:spPr>
+        <p:txBody>
+          <a:bodyPr wrap="square" lIns="177800" tIns="177800" rIns="177800" bIns="177800"/>
+          <a:lstStyle/>
+          <a:p>
+            <a:pPr algn="l"/>
+            <a:r>
+              <a:rPr lang="ru-RU" sz="1300" b="0">
+                <a:solidFill>
+                  <a:srgbClr val="5E6A75"/>
+                </a:solidFill>
+                <a:latin typeface="Aptos"/>
+                <a:cs typeface="Aptos"/>
+              </a:rPr>
+              <a:t>Повторяемость, повторное вступление в группу и восстановление после отказа узла</a:t>
             </a:r>
           </a:p>
         </p:txBody>
@@ -2137,8 +3081,8 @@
         </p:nvSpPr>
         <p:spPr>
           <a:xfrm>
-            <a:off x="685800" y="1691640"/>
-            <a:ext cx="10698480" cy="1280160"/>
+            <a:off x="685800" y="1600200"/>
+            <a:ext cx="3657600" cy="4114800"/>
           </a:xfrm>
           <a:prstGeom prst="roundRect">
             <a:avLst/>
@@ -2156,16 +3100,133 @@
           <a:bodyPr wrap="square" lIns="177800" tIns="177800" rIns="177800" bIns="177800"/>
           <a:lstStyle/>
           <a:p>
-            <a:pPr algn="ctr"/>
-            <a:r>
-              <a:rPr lang="ru-RU" sz="2000" b="1">
-                <a:solidFill>
-                  <a:srgbClr val="18212B"/>
-                </a:solidFill>
-                <a:latin typeface="Aptos"/>
-                <a:cs typeface="Aptos"/>
-              </a:rPr>
-              <a:t>Ограничение single-node WebSocket-архитектуры устранено за счёт распределённого real-time контура.</a:t>
+            <a:pPr algn="l"/>
+            <a:r>
+              <a:rPr lang="ru-RU" sz="1500" b="0">
+                <a:solidFill>
+                  <a:srgbClr val="18212B"/>
+                </a:solidFill>
+                <a:latin typeface="Aptos"/>
+                <a:cs typeface="Aptos"/>
+              </a:rPr>
+              <a:t>Серия 5 итераций</a:t>
+            </a:r>
+          </a:p>
+          <a:p>
+            <a:pPr algn="l"/>
+            <a:r>
+              <a:rPr lang="ru-RU" sz="1500" b="0">
+                <a:solidFill>
+                  <a:srgbClr val="18212B"/>
+                </a:solidFill>
+                <a:latin typeface="Aptos"/>
+                <a:cs typeface="Aptos"/>
+              </a:rPr>
+              <a:t/>
+            </a:r>
+          </a:p>
+          <a:p>
+            <a:pPr algn="l"/>
+            <a:r>
+              <a:rPr lang="ru-RU" sz="1500" b="0">
+                <a:solidFill>
+                  <a:srgbClr val="18212B"/>
+                </a:solidFill>
+                <a:latin typeface="Aptos"/>
+                <a:cs typeface="Aptos"/>
+              </a:rPr>
+              <a:t>successful 5 / 5</a:t>
+            </a:r>
+          </a:p>
+          <a:p>
+            <a:pPr algn="l"/>
+            <a:r>
+              <a:rPr lang="ru-RU" sz="1500" b="0">
+                <a:solidFill>
+                  <a:srgbClr val="18212B"/>
+                </a:solidFill>
+                <a:latin typeface="Aptos"/>
+                <a:cs typeface="Aptos"/>
+              </a:rPr>
+              <a:t/>
+            </a:r>
+          </a:p>
+          <a:p>
+            <a:pPr algn="l"/>
+            <a:r>
+              <a:rPr lang="ru-RU" sz="1500" b="0">
+                <a:solidFill>
+                  <a:srgbClr val="18212B"/>
+                </a:solidFill>
+                <a:latin typeface="Aptos"/>
+                <a:cs typeface="Aptos"/>
+              </a:rPr>
+              <a:t>min 5,5 мс</a:t>
+            </a:r>
+          </a:p>
+          <a:p>
+            <a:pPr algn="l"/>
+            <a:r>
+              <a:rPr lang="ru-RU" sz="1500" b="0">
+                <a:solidFill>
+                  <a:srgbClr val="18212B"/>
+                </a:solidFill>
+                <a:latin typeface="Aptos"/>
+                <a:cs typeface="Aptos"/>
+              </a:rPr>
+              <a:t>avg 8,4 мс</a:t>
+            </a:r>
+          </a:p>
+          <a:p>
+            <a:pPr algn="l"/>
+            <a:r>
+              <a:rPr lang="ru-RU" sz="1500" b="0">
+                <a:solidFill>
+                  <a:srgbClr val="18212B"/>
+                </a:solidFill>
+                <a:latin typeface="Aptos"/>
+                <a:cs typeface="Aptos"/>
+              </a:rPr>
+              <a:t>p50 9,1 мс</a:t>
+            </a:r>
+          </a:p>
+          <a:p>
+            <a:pPr algn="l"/>
+            <a:r>
+              <a:rPr lang="ru-RU" sz="1500" b="0">
+                <a:solidFill>
+                  <a:srgbClr val="18212B"/>
+                </a:solidFill>
+                <a:latin typeface="Aptos"/>
+                <a:cs typeface="Aptos"/>
+              </a:rPr>
+              <a:t>p95 11,6 мс</a:t>
+            </a:r>
+          </a:p>
+          <a:p>
+            <a:pPr algn="l"/>
+            <a:r>
+              <a:rPr lang="ru-RU" sz="1500" b="0">
+                <a:solidFill>
+                  <a:srgbClr val="18212B"/>
+                </a:solidFill>
+                <a:latin typeface="Aptos"/>
+                <a:cs typeface="Aptos"/>
+              </a:rPr>
+              <a:t/>
+            </a:r>
+          </a:p>
+          <a:p>
+            <a:pPr algn="l"/>
+            <a:r>
+              <a:rPr lang="ru-RU" sz="1500" b="0">
+                <a:solidFill>
+                  <a:srgbClr val="18212B"/>
+                </a:solidFill>
+                <a:latin typeface="Aptos"/>
+                <a:cs typeface="Aptos"/>
+              </a:rPr>
+              <a:t>Подтверждена повторяемость доставки.</a:t>
             </a:r>
           </a:p>
         </p:txBody>
@@ -2178,8 +3239,8 @@
         </p:nvSpPr>
         <p:spPr>
           <a:xfrm>
-            <a:off x="685800" y="3246120"/>
-            <a:ext cx="3383280" cy="1554480"/>
+            <a:off x="4434840" y="1600200"/>
+            <a:ext cx="3657600" cy="4114800"/>
           </a:xfrm>
           <a:prstGeom prst="roundRect">
             <a:avLst/>
@@ -2199,27 +3260,118 @@
           <a:p>
             <a:pPr algn="l"/>
             <a:r>
-              <a:rPr lang="ru-RU" sz="1400" b="1">
-                <a:solidFill>
-                  <a:srgbClr val="18212B"/>
-                </a:solidFill>
-                <a:latin typeface="Aptos"/>
-                <a:cs typeface="Aptos"/>
-              </a:rPr>
-              <a:t>Проблема</a:t>
-            </a:r>
-          </a:p>
-          <a:p>
-            <a:pPr algn="l"/>
-            <a:r>
-              <a:rPr lang="ru-RU" sz="1400" b="1">
-                <a:solidFill>
-                  <a:srgbClr val="18212B"/>
-                </a:solidFill>
-                <a:latin typeface="Aptos"/>
-                <a:cs typeface="Aptos"/>
-              </a:rPr>
-              <a:t>Без backplane событие теряется между узлами.</a:t>
+              <a:rPr lang="ru-RU" sz="1500" b="0">
+                <a:solidFill>
+                  <a:srgbClr val="18212B"/>
+                </a:solidFill>
+                <a:latin typeface="Aptos"/>
+                <a:cs typeface="Aptos"/>
+              </a:rPr>
+              <a:t>Rejoin после разрыва</a:t>
+            </a:r>
+          </a:p>
+          <a:p>
+            <a:pPr algn="l"/>
+            <a:r>
+              <a:rPr lang="ru-RU" sz="1500" b="0">
+                <a:solidFill>
+                  <a:srgbClr val="18212B"/>
+                </a:solidFill>
+                <a:latin typeface="Aptos"/>
+                <a:cs typeface="Aptos"/>
+              </a:rPr>
+              <a:t/>
+            </a:r>
+          </a:p>
+          <a:p>
+            <a:pPr algn="l"/>
+            <a:r>
+              <a:rPr lang="ru-RU" sz="1500" b="0">
+                <a:solidFill>
+                  <a:srgbClr val="18212B"/>
+                </a:solidFill>
+                <a:latin typeface="Aptos"/>
+                <a:cs typeface="Aptos"/>
+              </a:rPr>
+              <a:t>Новый connectionId</a:t>
+            </a:r>
+          </a:p>
+          <a:p>
+            <a:pPr algn="l"/>
+            <a:r>
+              <a:rPr lang="ru-RU" sz="1500" b="0">
+                <a:solidFill>
+                  <a:srgbClr val="18212B"/>
+                </a:solidFill>
+                <a:latin typeface="Aptos"/>
+                <a:cs typeface="Aptos"/>
+              </a:rPr>
+              <a:t>повторный JoinReportGroupAsync</a:t>
+            </a:r>
+          </a:p>
+          <a:p>
+            <a:pPr algn="l"/>
+            <a:r>
+              <a:rPr lang="ru-RU" sz="1500" b="0">
+                <a:solidFill>
+                  <a:srgbClr val="18212B"/>
+                </a:solidFill>
+                <a:latin typeface="Aptos"/>
+                <a:cs typeface="Aptos"/>
+              </a:rPr>
+              <a:t/>
+            </a:r>
+          </a:p>
+          <a:p>
+            <a:pPr algn="l"/>
+            <a:r>
+              <a:rPr lang="ru-RU" sz="1500" b="0">
+                <a:solidFill>
+                  <a:srgbClr val="18212B"/>
+                </a:solidFill>
+                <a:latin typeface="Aptos"/>
+                <a:cs typeface="Aptos"/>
+              </a:rPr>
+              <a:t>rejoin 12,9 мс</a:t>
+            </a:r>
+          </a:p>
+          <a:p>
+            <a:pPr algn="l"/>
+            <a:r>
+              <a:rPr lang="ru-RU" sz="1500" b="0">
+                <a:solidFill>
+                  <a:srgbClr val="18212B"/>
+                </a:solidFill>
+                <a:latin typeface="Aptos"/>
+                <a:cs typeface="Aptos"/>
+              </a:rPr>
+              <a:t>delivery 6,6 мс</a:t>
+            </a:r>
+          </a:p>
+          <a:p>
+            <a:pPr algn="l"/>
+            <a:r>
+              <a:rPr lang="ru-RU" sz="1500" b="0">
+                <a:solidFill>
+                  <a:srgbClr val="18212B"/>
+                </a:solidFill>
+                <a:latin typeface="Aptos"/>
+                <a:cs typeface="Aptos"/>
+              </a:rPr>
+              <a:t/>
+            </a:r>
+          </a:p>
+          <a:p>
+            <a:pPr algn="l"/>
+            <a:r>
+              <a:rPr lang="ru-RU" sz="1500" b="0">
+                <a:solidFill>
+                  <a:srgbClr val="18212B"/>
+                </a:solidFill>
+                <a:latin typeface="Aptos"/>
+                <a:cs typeface="Aptos"/>
+              </a:rPr>
+              <a:t>Подтверждена повторная подписка.</a:t>
             </a:r>
           </a:p>
         </p:txBody>
@@ -2232,8 +3384,8 @@
         </p:nvSpPr>
         <p:spPr>
           <a:xfrm>
-            <a:off x="4251960" y="3246120"/>
-            <a:ext cx="3383280" cy="1554480"/>
+            <a:off x="8183880" y="1600200"/>
+            <a:ext cx="3657600" cy="4114800"/>
           </a:xfrm>
           <a:prstGeom prst="roundRect">
             <a:avLst/>
@@ -2253,41 +3405,280 @@
           <a:p>
             <a:pPr algn="l"/>
             <a:r>
-              <a:rPr lang="ru-RU" sz="1400" b="1">
-                <a:solidFill>
-                  <a:srgbClr val="18212B"/>
-                </a:solidFill>
-                <a:latin typeface="Aptos"/>
-                <a:cs typeface="Aptos"/>
-              </a:rPr>
-              <a:t>Решение</a:t>
-            </a:r>
-          </a:p>
-          <a:p>
-            <a:pPr algn="l"/>
-            <a:r>
-              <a:rPr lang="ru-RU" sz="1400" b="1">
-                <a:solidFill>
-                  <a:srgbClr val="18212B"/>
-                </a:solidFill>
-                <a:latin typeface="Aptos"/>
-                <a:cs typeface="Aptos"/>
-              </a:rPr>
-              <a:t>SignalR + Redis backplane + nginx + два app-api.</a:t>
-            </a:r>
-          </a:p>
-        </p:txBody>
-      </p:sp>
-      <p:sp>
-        <p:nvSpPr>
-          <p:cNvPr id="23" name="Shape 23"/>
-          <p:cNvSpPr txBox="1"/>
-          <p:nvPr/>
-        </p:nvSpPr>
-        <p:spPr>
-          <a:xfrm>
-            <a:off x="7818120" y="3246120"/>
-            <a:ext cx="3383280" cy="1554480"/>
+              <a:rPr lang="ru-RU" sz="1500" b="0">
+                <a:solidFill>
+                  <a:srgbClr val="18212B"/>
+                </a:solidFill>
+                <a:latin typeface="Aptos"/>
+                <a:cs typeface="Aptos"/>
+              </a:rPr>
+              <a:t>Failover узла</a:t>
+            </a:r>
+          </a:p>
+          <a:p>
+            <a:pPr algn="l"/>
+            <a:r>
+              <a:rPr lang="ru-RU" sz="1500" b="0">
+                <a:solidFill>
+                  <a:srgbClr val="18212B"/>
+                </a:solidFill>
+                <a:latin typeface="Aptos"/>
+                <a:cs typeface="Aptos"/>
+              </a:rPr>
+              <a:t/>
+            </a:r>
+          </a:p>
+          <a:p>
+            <a:pPr algn="l"/>
+            <a:r>
+              <a:rPr lang="ru-RU" sz="1500" b="0">
+                <a:solidFill>
+                  <a:srgbClr val="18212B"/>
+                </a:solidFill>
+                <a:latin typeface="Aptos"/>
+                <a:cs typeface="Aptos"/>
+              </a:rPr>
+              <a:t>Контейнер app-api-2 остановлен</a:t>
+            </a:r>
+          </a:p>
+          <a:p>
+            <a:pPr algn="l"/>
+            <a:r>
+              <a:rPr lang="ru-RU" sz="1500" b="0">
+                <a:solidFill>
+                  <a:srgbClr val="18212B"/>
+                </a:solidFill>
+                <a:latin typeface="Aptos"/>
+                <a:cs typeface="Aptos"/>
+              </a:rPr>
+              <a:t>клиент переподключился через nginx к app-api-1</a:t>
+            </a:r>
+          </a:p>
+          <a:p>
+            <a:pPr algn="l"/>
+            <a:r>
+              <a:rPr lang="ru-RU" sz="1500" b="0">
+                <a:solidFill>
+                  <a:srgbClr val="18212B"/>
+                </a:solidFill>
+                <a:latin typeface="Aptos"/>
+                <a:cs typeface="Aptos"/>
+              </a:rPr>
+              <a:t/>
+            </a:r>
+          </a:p>
+          <a:p>
+            <a:pPr algn="l"/>
+            <a:r>
+              <a:rPr lang="ru-RU" sz="1500" b="0">
+                <a:solidFill>
+                  <a:srgbClr val="18212B"/>
+                </a:solidFill>
+                <a:latin typeface="Aptos"/>
+                <a:cs typeface="Aptos"/>
+              </a:rPr>
+              <a:t>reconnect 240,3 мс</a:t>
+            </a:r>
+          </a:p>
+          <a:p>
+            <a:pPr algn="l"/>
+            <a:r>
+              <a:rPr lang="ru-RU" sz="1500" b="0">
+                <a:solidFill>
+                  <a:srgbClr val="18212B"/>
+                </a:solidFill>
+                <a:latin typeface="Aptos"/>
+                <a:cs typeface="Aptos"/>
+              </a:rPr>
+              <a:t>delivery 7,3 мс</a:t>
+            </a:r>
+          </a:p>
+          <a:p>
+            <a:pPr algn="l"/>
+            <a:r>
+              <a:rPr lang="ru-RU" sz="1500" b="0">
+                <a:solidFill>
+                  <a:srgbClr val="18212B"/>
+                </a:solidFill>
+                <a:latin typeface="Aptos"/>
+                <a:cs typeface="Aptos"/>
+              </a:rPr>
+              <a:t/>
+            </a:r>
+          </a:p>
+          <a:p>
+            <a:pPr algn="l"/>
+            <a:r>
+              <a:rPr lang="ru-RU" sz="1500" b="0">
+                <a:solidFill>
+                  <a:srgbClr val="18212B"/>
+                </a:solidFill>
+                <a:latin typeface="Aptos"/>
+                <a:cs typeface="Aptos"/>
+              </a:rPr>
+              <a:t>Подтверждено восстановление после отказа узла.</a:t>
+            </a:r>
+          </a:p>
+        </p:txBody>
+      </p:sp>
+      <p:sp>
+        <p:nvSpPr>
+          <p:cNvPr id="900" name="Shape 900"/>
+          <p:cNvSpPr txBox="1"/>
+          <p:nvPr/>
+        </p:nvSpPr>
+        <p:spPr>
+          <a:xfrm>
+            <a:off x="594360" y="6510528"/>
+            <a:ext cx="10972800" cy="201168"/>
+          </a:xfrm>
+          <a:prstGeom prst="roundRect">
+            <a:avLst/>
+          </a:prstGeom>
+          <a:noFill/>
+          <a:ln>
+            <a:noFill/>
+          </a:ln>
+        </p:spPr>
+        <p:txBody>
+          <a:bodyPr wrap="square" lIns="177800" tIns="177800" rIns="177800" bIns="177800"/>
+          <a:lstStyle/>
+          <a:p>
+            <a:pPr algn="l"/>
+            <a:r>
+              <a:rPr lang="ru-RU" sz="800" b="0">
+                <a:solidFill>
+                  <a:srgbClr val="5E6A75"/>
+                </a:solidFill>
+                <a:latin typeface="Aptos"/>
+                <a:cs typeface="Aptos"/>
+              </a:rPr>
+              <a:t>Real-time scale-out · 08</a:t>
+            </a:r>
+          </a:p>
+        </p:txBody>
+      </p:sp>
+    </p:spTree>
+  </p:cSld>
+  <p:clrMapOvr>
+    <a:masterClrMapping/>
+  </p:clrMapOvr>
+</p:sld>
+</file>
+
+<file path=ppt/slides/slide9.xml><?xml version="1.0" encoding="utf-8"?>
+<p:sld xmlns:a="http://schemas.openxmlformats.org/drawingml/2006/main" xmlns:r="http://schemas.openxmlformats.org/officeDocument/2006/relationships" xmlns:p="http://schemas.openxmlformats.org/presentationml/2006/main">
+  <p:cSld>
+    <p:bg>
+      <p:bgPr>
+        <a:solidFill>
+          <a:srgbClr val="F6F3EC"/>
+        </a:solidFill>
+        <a:effectLst/>
+      </p:bgPr>
+    </p:bg>
+    <p:spTree>
+      <p:nvGrpSpPr>
+        <p:cNvPr id="1" name=""/>
+        <p:cNvGrpSpPr/>
+        <p:nvPr/>
+      </p:nvGrpSpPr>
+      <p:grpSpPr>
+        <a:xfrm>
+          <a:off x="0" y="0"/>
+          <a:ext cx="0" cy="0"/>
+          <a:chOff x="0" y="0"/>
+          <a:chExt cx="0" cy="0"/>
+        </a:xfrm>
+      </p:grpSpPr>
+      <p:sp>
+        <p:nvSpPr>
+          <p:cNvPr id="10" name="Shape 10"/>
+          <p:cNvSpPr txBox="1"/>
+          <p:nvPr/>
+        </p:nvSpPr>
+        <p:spPr>
+          <a:xfrm>
+            <a:off x="594360" y="411480"/>
+            <a:ext cx="10881360" cy="658368"/>
+          </a:xfrm>
+          <a:prstGeom prst="roundRect">
+            <a:avLst/>
+          </a:prstGeom>
+          <a:noFill/>
+          <a:ln>
+            <a:noFill/>
+          </a:ln>
+        </p:spPr>
+        <p:txBody>
+          <a:bodyPr wrap="square" lIns="177800" tIns="177800" rIns="177800" bIns="177800"/>
+          <a:lstStyle/>
+          <a:p>
+            <a:pPr algn="l"/>
+            <a:r>
+              <a:rPr lang="ru-RU" sz="3000" b="1">
+                <a:solidFill>
+                  <a:srgbClr val="18212B"/>
+                </a:solidFill>
+                <a:latin typeface="Aptos"/>
+                <a:cs typeface="Aptos"/>
+              </a:rPr>
+              <a:t>Вывод</a:t>
+            </a:r>
+          </a:p>
+        </p:txBody>
+      </p:sp>
+      <p:sp>
+        <p:nvSpPr>
+          <p:cNvPr id="20" name="Shape 20"/>
+          <p:cNvSpPr txBox="1"/>
+          <p:nvPr/>
+        </p:nvSpPr>
+        <p:spPr>
+          <a:xfrm>
+            <a:off x="685800" y="1554480"/>
+            <a:ext cx="10835640" cy="1371600"/>
+          </a:xfrm>
+          <a:prstGeom prst="roundRect">
+            <a:avLst/>
+          </a:prstGeom>
+          <a:solidFill>
+            <a:srgbClr val="E8F3F1"/>
+          </a:solidFill>
+          <a:ln w="12700">
+            <a:solidFill>
+              <a:srgbClr val="0B6E69"/>
+            </a:solidFill>
+          </a:ln>
+        </p:spPr>
+        <p:txBody>
+          <a:bodyPr wrap="square" lIns="177800" tIns="177800" rIns="177800" bIns="177800"/>
+          <a:lstStyle/>
+          <a:p>
+            <a:pPr algn="ctr"/>
+            <a:r>
+              <a:rPr lang="ru-RU" sz="1800" b="1">
+                <a:solidFill>
+                  <a:srgbClr val="18212B"/>
+                </a:solidFill>
+                <a:latin typeface="Aptos"/>
+                <a:cs typeface="Aptos"/>
+              </a:rPr>
+              <a:t>Ограничение single-node WebSocket-архитектуры устранено за счёт распределённого real-time контура; тезис практики подтверждён экспериментально.</a:t>
+            </a:r>
+          </a:p>
+        </p:txBody>
+      </p:sp>
+      <p:sp>
+        <p:nvSpPr>
+          <p:cNvPr id="21" name="Shape 21"/>
+          <p:cNvSpPr txBox="1"/>
+          <p:nvPr/>
+        </p:nvSpPr>
+        <p:spPr>
+          <a:xfrm>
+            <a:off x="685800" y="3108960"/>
+            <a:ext cx="3520440" cy="2606040"/>
           </a:xfrm>
           <a:prstGeom prst="roundRect">
             <a:avLst/>
@@ -2314,6 +3705,140 @@
                 <a:latin typeface="Aptos"/>
                 <a:cs typeface="Aptos"/>
               </a:rPr>
+              <a:t>Проблема</a:t>
+            </a:r>
+          </a:p>
+          <a:p>
+            <a:pPr algn="l"/>
+            <a:r>
+              <a:rPr lang="ru-RU" sz="1400" b="1">
+                <a:solidFill>
+                  <a:srgbClr val="18212B"/>
+                </a:solidFill>
+                <a:latin typeface="Aptos"/>
+                <a:cs typeface="Aptos"/>
+              </a:rPr>
+              <a:t/>
+            </a:r>
+          </a:p>
+          <a:p>
+            <a:pPr algn="l"/>
+            <a:r>
+              <a:rPr lang="ru-RU" sz="1400" b="1">
+                <a:solidFill>
+                  <a:srgbClr val="18212B"/>
+                </a:solidFill>
+                <a:latin typeface="Aptos"/>
+                <a:cs typeface="Aptos"/>
+              </a:rPr>
+              <a:t>Single-node SignalR: события не пересекают границу узла.</a:t>
+            </a:r>
+          </a:p>
+        </p:txBody>
+      </p:sp>
+      <p:sp>
+        <p:nvSpPr>
+          <p:cNvPr id="22" name="Shape 22"/>
+          <p:cNvSpPr txBox="1"/>
+          <p:nvPr/>
+        </p:nvSpPr>
+        <p:spPr>
+          <a:xfrm>
+            <a:off x="4343400" y="3108960"/>
+            <a:ext cx="3520440" cy="2606040"/>
+          </a:xfrm>
+          <a:prstGeom prst="roundRect">
+            <a:avLst/>
+          </a:prstGeom>
+          <a:solidFill>
+            <a:srgbClr val="FFFFFF"/>
+          </a:solidFill>
+          <a:ln w="12700">
+            <a:solidFill>
+              <a:srgbClr val="D7D2C7"/>
+            </a:solidFill>
+          </a:ln>
+        </p:spPr>
+        <p:txBody>
+          <a:bodyPr wrap="square" lIns="177800" tIns="177800" rIns="177800" bIns="177800"/>
+          <a:lstStyle/>
+          <a:p>
+            <a:pPr algn="l"/>
+            <a:r>
+              <a:rPr lang="ru-RU" sz="1400" b="1">
+                <a:solidFill>
+                  <a:srgbClr val="18212B"/>
+                </a:solidFill>
+                <a:latin typeface="Aptos"/>
+                <a:cs typeface="Aptos"/>
+              </a:rPr>
+              <a:t>Решение</a:t>
+            </a:r>
+          </a:p>
+          <a:p>
+            <a:pPr algn="l"/>
+            <a:r>
+              <a:rPr lang="ru-RU" sz="1400" b="1">
+                <a:solidFill>
+                  <a:srgbClr val="18212B"/>
+                </a:solidFill>
+                <a:latin typeface="Aptos"/>
+                <a:cs typeface="Aptos"/>
+              </a:rPr>
+              <a:t/>
+            </a:r>
+          </a:p>
+          <a:p>
+            <a:pPr algn="l"/>
+            <a:r>
+              <a:rPr lang="ru-RU" sz="1400" b="1">
+                <a:solidFill>
+                  <a:srgbClr val="18212B"/>
+                </a:solidFill>
+                <a:latin typeface="Aptos"/>
+                <a:cs typeface="Aptos"/>
+              </a:rPr>
+              <a:t>SignalR + Redis backplane + nginx + два app-api; общий код, конфигурация через переменную окружения.</a:t>
+            </a:r>
+          </a:p>
+        </p:txBody>
+      </p:sp>
+      <p:sp>
+        <p:nvSpPr>
+          <p:cNvPr id="23" name="Shape 23"/>
+          <p:cNvSpPr txBox="1"/>
+          <p:nvPr/>
+        </p:nvSpPr>
+        <p:spPr>
+          <a:xfrm>
+            <a:off x="8001000" y="3108960"/>
+            <a:ext cx="3520440" cy="2606040"/>
+          </a:xfrm>
+          <a:prstGeom prst="roundRect">
+            <a:avLst/>
+          </a:prstGeom>
+          <a:solidFill>
+            <a:srgbClr val="FFFFFF"/>
+          </a:solidFill>
+          <a:ln w="12700">
+            <a:solidFill>
+              <a:srgbClr val="D7D2C7"/>
+            </a:solidFill>
+          </a:ln>
+        </p:spPr>
+        <p:txBody>
+          <a:bodyPr wrap="square" lIns="177800" tIns="177800" rIns="177800" bIns="177800"/>
+          <a:lstStyle/>
+          <a:p>
+            <a:pPr algn="l"/>
+            <a:r>
+              <a:rPr lang="ru-RU" sz="1400" b="1">
+                <a:solidFill>
+                  <a:srgbClr val="18212B"/>
+                </a:solidFill>
+                <a:latin typeface="Aptos"/>
+                <a:cs typeface="Aptos"/>
+              </a:rPr>
               <a:t>Доказательство</a:t>
             </a:r>
           </a:p>
@@ -2327,7 +3852,20 @@
                 <a:latin typeface="Aptos"/>
                 <a:cs typeface="Aptos"/>
               </a:rPr>
-              <a:t>Delivery, серия, rejoin, failover.</a:t>
+              <a:t/>
+            </a:r>
+          </a:p>
+          <a:p>
+            <a:pPr algn="l"/>
+            <a:r>
+              <a:rPr lang="ru-RU" sz="1400" b="1">
+                <a:solidFill>
+                  <a:srgbClr val="18212B"/>
+                </a:solidFill>
+                <a:latin typeface="Aptos"/>
+                <a:cs typeface="Aptos"/>
+              </a:rPr>
+              <a:t>Delivery (без / с) · серия 5 / 5 · rejoin · failover — воспроизводимый Docker Compose стенд.</a:t>
             </a:r>
           </a:p>
         </p:txBody>
@@ -2364,7 +3902,7 @@
                 <a:latin typeface="Aptos"/>
                 <a:cs typeface="Aptos"/>
               </a:rPr>
-              <a:t>Real-time scale-out · 08</a:t>
+              <a:t>Real-time scale-out · 09</a:t>
             </a:r>
           </a:p>
         </p:txBody>

</xml_diff>

<commit_message>
Update PPTX and PDF files for final qualifying work, incorporating revisions to defense drafts and enhancing presentation content. Modify build script to improve clarity and accuracy of slide descriptions, ensuring alignment with project standards.
</commit_message>
<xml_diff>
--- a/build/pptx/practice-defense-draft.pptx
+++ b/build/pptx/practice-defense-draft.pptx
@@ -806,7 +806,7 @@
                 <a:latin typeface="Aptos"/>
                 <a:cs typeface="Aptos"/>
               </a:rPr>
-              <a:t>Нет масштабирования; один узел — точка отказа</a:t>
+              <a:t>Нет масштабирования; один узел — единственная точка отказа</a:t>
             </a:r>
           </a:p>
         </p:txBody>
@@ -847,7 +847,7 @@
                 <a:latin typeface="Aptos"/>
                 <a:cs typeface="Aptos"/>
               </a:rPr>
-              <a:t>Несколько экземпляров без backplane</a:t>
+              <a:t>Несколько экземпляров без общего канала</a:t>
             </a:r>
           </a:p>
           <a:p>
@@ -860,7 +860,7 @@
                 <a:latin typeface="Aptos"/>
                 <a:cs typeface="Aptos"/>
               </a:rPr>
-              <a:t>Real-time пространство фрагментируется по узлам</a:t>
+              <a:t>События не доходят до клиентов, подключённых к другим узлам</a:t>
             </a:r>
           </a:p>
         </p:txBody>
@@ -901,7 +901,7 @@
                 <a:latin typeface="Aptos"/>
                 <a:cs typeface="Aptos"/>
               </a:rPr>
-              <a:t>Sticky sessions</a:t>
+              <a:t>Привязка клиента к узлу (sticky)</a:t>
             </a:r>
           </a:p>
           <a:p>
@@ -914,7 +914,7 @@
                 <a:latin typeface="Aptos"/>
                 <a:cs typeface="Aptos"/>
               </a:rPr>
-              <a:t>Удерживают клиента на узле, но не доставляют события на другие</a:t>
+              <a:t>Клиент остаётся на одном узле, но события на другие не приходят</a:t>
             </a:r>
           </a:p>
         </p:txBody>
@@ -955,7 +955,7 @@
                 <a:latin typeface="Aptos"/>
                 <a:cs typeface="Aptos"/>
               </a:rPr>
-              <a:t>Broker / event bus</a:t>
+              <a:t>Внешняя шина событий</a:t>
             </a:r>
           </a:p>
           <a:p>
@@ -968,7 +968,7 @@
                 <a:latin typeface="Aptos"/>
                 <a:cs typeface="Aptos"/>
               </a:rPr>
-              <a:t>Даёт межузловую доставку, но требует схем событий и persistence</a:t>
+              <a:t>Доставка между узлами есть, но требуется отдельная схема событий</a:t>
             </a:r>
           </a:p>
         </p:txBody>
@@ -1009,7 +1009,7 @@
                 <a:latin typeface="Aptos"/>
                 <a:cs typeface="Aptos"/>
               </a:rPr>
-              <a:t>Managed real-time service</a:t>
+              <a:t>Облачный real-time сервис</a:t>
             </a:r>
           </a:p>
           <a:p>
@@ -1022,7 +1022,7 @@
                 <a:latin typeface="Aptos"/>
                 <a:cs typeface="Aptos"/>
               </a:rPr>
-              <a:t>Уменьшает контроль над self-hosted контуром</a:t>
+              <a:t>Готовое решение, но снижает контроль над собственным контуром</a:t>
             </a:r>
           </a:p>
         </p:txBody>
@@ -1076,7 +1076,7 @@
                 <a:latin typeface="Aptos"/>
                 <a:cs typeface="Aptos"/>
               </a:rPr>
-              <a:t>self-hosted, без перестройки логики, transient pub/sub</a:t>
+              <a:t>Штатный механизм, без перестройки кода, подходит для событий интерфейса</a:t>
             </a:r>
           </a:p>
         </p:txBody>
@@ -1113,7 +1113,7 @@
                 <a:latin typeface="Aptos"/>
                 <a:cs typeface="Aptos"/>
               </a:rPr>
-              <a:t>Критерии выбора: совместимость с self-hosted стендом, минимальная перестройка доменной логики, наличие штатной поддержки в ASP.NET Core SignalR, пригодность для transient UI-событий и воспроизводимость на локальном Docker Compose стенде.</a:t>
+              <a:t>Критерии выбора: запускается на локальном стенде, сохраняет существующий код доставки событий, штатно поддерживается в ASP.NET Core SignalR, подходит для коротких событий интерфейса и легко воспроизводится.</a:t>
             </a:r>
           </a:p>
         </p:txBody>
@@ -1855,7 +1855,7 @@
                 <a:latin typeface="Aptos"/>
                 <a:cs typeface="Aptos"/>
               </a:rPr>
-              <a:t>Backend-конфигурация, диагностика, стенд и проверочный клиент</a:t>
+              <a:t>Подключён межузловой канал, добавлена диагностика, собран стенд и клиент проверки</a:t>
             </a:r>
           </a:p>
         </p:txBody>
@@ -1870,73 +1870,6 @@
           <a:xfrm>
             <a:off x="685800" y="1554480"/>
             <a:ext cx="5349240" cy="2194560"/>
-          </a:xfrm>
-          <a:prstGeom prst="roundRect">
-            <a:avLst/>
-          </a:prstGeom>
-          <a:solidFill>
-            <a:srgbClr val="FFFFFF"/>
-          </a:solidFill>
-          <a:ln w="12700">
-            <a:solidFill>
-              <a:srgbClr val="0B6E69"/>
-            </a:solidFill>
-          </a:ln>
-        </p:spPr>
-        <p:txBody>
-          <a:bodyPr wrap="square" lIns="177800" tIns="177800" rIns="177800" bIns="177800"/>
-          <a:lstStyle/>
-          <a:p>
-            <a:pPr algn="l"/>
-            <a:r>
-              <a:rPr lang="ru-RU" sz="1400" b="0">
-                <a:solidFill>
-                  <a:srgbClr val="18212B"/>
-                </a:solidFill>
-                <a:latin typeface="Aptos"/>
-                <a:cs typeface="Aptos"/>
-              </a:rPr>
-              <a:t>1 · Redis backplane для SignalR</a:t>
-            </a:r>
-          </a:p>
-          <a:p>
-            <a:pPr algn="l"/>
-            <a:r>
-              <a:rPr lang="ru-RU" sz="1400" b="0">
-                <a:solidFill>
-                  <a:srgbClr val="18212B"/>
-                </a:solidFill>
-                <a:latin typeface="Aptos"/>
-                <a:cs typeface="Aptos"/>
-              </a:rPr>
-              <a:t/>
-            </a:r>
-          </a:p>
-          <a:p>
-            <a:pPr algn="l"/>
-            <a:r>
-              <a:rPr lang="ru-RU" sz="1400" b="0">
-                <a:solidFill>
-                  <a:srgbClr val="18212B"/>
-                </a:solidFill>
-                <a:latin typeface="Aptos"/>
-                <a:cs typeface="Aptos"/>
-              </a:rPr>
-              <a:t>AddStackExchangeRedis с prefix app-api-realtime; включается переменной REDIS_CONNECTION_STRING — один и тот же код в обоих режимах.</a:t>
-            </a:r>
-          </a:p>
-        </p:txBody>
-      </p:sp>
-      <p:sp>
-        <p:nvSpPr>
-          <p:cNvPr id="21" name="Shape 21"/>
-          <p:cNvSpPr txBox="1"/>
-          <p:nvPr/>
-        </p:nvSpPr>
-        <p:spPr>
-          <a:xfrm>
-            <a:off x="685800" y="3840480"/>
-            <a:ext cx="5349240" cy="1874520"/>
           </a:xfrm>
           <a:prstGeom prst="roundRect">
             <a:avLst/>
@@ -1963,7 +1896,7 @@
                 <a:latin typeface="Aptos"/>
                 <a:cs typeface="Aptos"/>
               </a:rPr>
-              <a:t>2 · Диагностический контур</a:t>
+              <a:t>1 · Межузловая доставка событий</a:t>
             </a:r>
           </a:p>
           <a:p>
@@ -1989,21 +1922,21 @@
                 <a:latin typeface="Aptos"/>
                 <a:cs typeface="Aptos"/>
               </a:rPr>
-              <a:t>SERVER_INSTANCE_ID, GetConnectionDiagnosticsAsync(), логирование подключения, вступления в группу и отправки события.</a:t>
-            </a:r>
-          </a:p>
-        </p:txBody>
-      </p:sp>
-      <p:sp>
-        <p:nvSpPr>
-          <p:cNvPr id="22" name="Shape 22"/>
-          <p:cNvSpPr txBox="1"/>
-          <p:nvPr/>
-        </p:nvSpPr>
-        <p:spPr>
-          <a:xfrm>
-            <a:off x="6172200" y="1554480"/>
-            <a:ext cx="5349240" cy="2194560"/>
+              <a:t>К SignalR подключён Redis backplane. Включается переменной окружения — один и тот же код работает и в режиме с межузловым каналом, и без него.</a:t>
+            </a:r>
+          </a:p>
+        </p:txBody>
+      </p:sp>
+      <p:sp>
+        <p:nvSpPr>
+          <p:cNvPr id="21" name="Shape 21"/>
+          <p:cNvSpPr txBox="1"/>
+          <p:nvPr/>
+        </p:nvSpPr>
+        <p:spPr>
+          <a:xfrm>
+            <a:off x="685800" y="3840480"/>
+            <a:ext cx="5349240" cy="1874520"/>
           </a:xfrm>
           <a:prstGeom prst="roundRect">
             <a:avLst/>
@@ -2030,7 +1963,7 @@
                 <a:latin typeface="Aptos"/>
                 <a:cs typeface="Aptos"/>
               </a:rPr>
-              <a:t>3 · Multi-instance стенд</a:t>
+              <a:t>2 · Диагностика подключения</a:t>
             </a:r>
           </a:p>
           <a:p>
@@ -2056,21 +1989,21 @@
                 <a:latin typeface="Aptos"/>
                 <a:cs typeface="Aptos"/>
               </a:rPr>
-              <a:t>docker-compose.thesis.yml: app-api-1, app-api-2, Redis, PostgreSQL, nginx; override .no-backplane.yml для воспроизведения исходной проблемы.</a:t>
-            </a:r>
-          </a:p>
-        </p:txBody>
-      </p:sp>
-      <p:sp>
-        <p:nvSpPr>
-          <p:cNvPr id="23" name="Shape 23"/>
-          <p:cNvSpPr txBox="1"/>
-          <p:nvPr/>
-        </p:nvSpPr>
-        <p:spPr>
-          <a:xfrm>
-            <a:off x="6172200" y="3840480"/>
-            <a:ext cx="5349240" cy="1874520"/>
+              <a:t>Узел сообщает свой идентификатор и идентификатор соединения; ключевые события жизненного цикла соединения логируются.</a:t>
+            </a:r>
+          </a:p>
+        </p:txBody>
+      </p:sp>
+      <p:sp>
+        <p:nvSpPr>
+          <p:cNvPr id="22" name="Shape 22"/>
+          <p:cNvSpPr txBox="1"/>
+          <p:nvPr/>
+        </p:nvSpPr>
+        <p:spPr>
+          <a:xfrm>
+            <a:off x="6172200" y="1554480"/>
+            <a:ext cx="5349240" cy="2194560"/>
           </a:xfrm>
           <a:prstGeom prst="roundRect">
             <a:avLst/>
@@ -2097,7 +2030,7 @@
                 <a:latin typeface="Aptos"/>
                 <a:cs typeface="Aptos"/>
               </a:rPr>
-              <a:t>4 · Проверочный клиент на Node.js</a:t>
+              <a:t>3 · Многоэкземплярный стенд</a:t>
             </a:r>
           </a:p>
           <a:p>
@@ -2123,7 +2056,74 @@
                 <a:latin typeface="Aptos"/>
                 <a:cs typeface="Aptos"/>
               </a:rPr>
-              <a:t>realtime-scaleout-check.mjs: одиночная доставка, серия, rejoin, failover.</a:t>
+              <a:t>Два экземпляра backend за nginx, общая база данных и Redis, отдельный режим без межузлового канала — для воспроизведения исходной проблемы.</a:t>
+            </a:r>
+          </a:p>
+        </p:txBody>
+      </p:sp>
+      <p:sp>
+        <p:nvSpPr>
+          <p:cNvPr id="23" name="Shape 23"/>
+          <p:cNvSpPr txBox="1"/>
+          <p:nvPr/>
+        </p:nvSpPr>
+        <p:spPr>
+          <a:xfrm>
+            <a:off x="6172200" y="3840480"/>
+            <a:ext cx="5349240" cy="1874520"/>
+          </a:xfrm>
+          <a:prstGeom prst="roundRect">
+            <a:avLst/>
+          </a:prstGeom>
+          <a:solidFill>
+            <a:srgbClr val="FFFFFF"/>
+          </a:solidFill>
+          <a:ln w="12700">
+            <a:solidFill>
+              <a:srgbClr val="D7D2C7"/>
+            </a:solidFill>
+          </a:ln>
+        </p:spPr>
+        <p:txBody>
+          <a:bodyPr wrap="square" lIns="177800" tIns="177800" rIns="177800" bIns="177800"/>
+          <a:lstStyle/>
+          <a:p>
+            <a:pPr algn="l"/>
+            <a:r>
+              <a:rPr lang="ru-RU" sz="1400" b="0">
+                <a:solidFill>
+                  <a:srgbClr val="18212B"/>
+                </a:solidFill>
+                <a:latin typeface="Aptos"/>
+                <a:cs typeface="Aptos"/>
+              </a:rPr>
+              <a:t>4 · Проверочный клиент</a:t>
+            </a:r>
+          </a:p>
+          <a:p>
+            <a:pPr algn="l"/>
+            <a:r>
+              <a:rPr lang="ru-RU" sz="1400" b="0">
+                <a:solidFill>
+                  <a:srgbClr val="18212B"/>
+                </a:solidFill>
+                <a:latin typeface="Aptos"/>
+                <a:cs typeface="Aptos"/>
+              </a:rPr>
+              <a:t/>
+            </a:r>
+          </a:p>
+          <a:p>
+            <a:pPr algn="l"/>
+            <a:r>
+              <a:rPr lang="ru-RU" sz="1400" b="0">
+                <a:solidFill>
+                  <a:srgbClr val="18212B"/>
+                </a:solidFill>
+                <a:latin typeface="Aptos"/>
+                <a:cs typeface="Aptos"/>
+              </a:rPr>
+              <a:t>Подключается к разным узлам, фиксирует доставку события и поддерживает четыре сценария проверки.</a:t>
             </a:r>
           </a:p>
         </p:txBody>
@@ -2287,11 +2287,11 @@
             <a:avLst/>
           </a:prstGeom>
           <a:solidFill>
-            <a:srgbClr val="E8F3F1"/>
+            <a:srgbClr val="FFFFFF"/>
           </a:solidFill>
           <a:ln w="12700">
             <a:solidFill>
-              <a:srgbClr val="0B6E69"/>
+              <a:srgbClr val="D7D2C7"/>
             </a:solidFill>
           </a:ln>
         </p:spPr>
@@ -2301,7 +2301,7 @@
           <a:p>
             <a:pPr algn="l"/>
             <a:r>
-              <a:rPr lang="ru-RU" sz="1500" b="1">
+              <a:rPr lang="ru-RU" sz="1500" b="0">
                 <a:solidFill>
                   <a:srgbClr val="18212B"/>
                 </a:solidFill>
@@ -2314,7 +2314,7 @@
           <a:p>
             <a:pPr algn="l"/>
             <a:r>
-              <a:rPr lang="ru-RU" sz="1500" b="1">
+              <a:rPr lang="ru-RU" sz="1500" b="0">
                 <a:solidFill>
                   <a:srgbClr val="18212B"/>
                 </a:solidFill>
@@ -2327,20 +2327,20 @@
           <a:p>
             <a:pPr algn="l"/>
             <a:r>
-              <a:rPr lang="ru-RU" sz="1500" b="1">
-                <a:solidFill>
-                  <a:srgbClr val="18212B"/>
-                </a:solidFill>
-                <a:latin typeface="Aptos"/>
-                <a:cs typeface="Aptos"/>
-              </a:rPr>
-              <a:t>• Multi-instance без Redis backplane — воспроизведение проблемы</a:t>
-            </a:r>
-          </a:p>
-          <a:p>
-            <a:pPr algn="l"/>
-            <a:r>
-              <a:rPr lang="ru-RU" sz="1500" b="1">
+              <a:rPr lang="ru-RU" sz="1500" b="0">
+                <a:solidFill>
+                  <a:srgbClr val="18212B"/>
+                </a:solidFill>
+                <a:latin typeface="Aptos"/>
+                <a:cs typeface="Aptos"/>
+              </a:rPr>
+              <a:t>• Без межузлового канала — воспроизведение проблемы</a:t>
+            </a:r>
+          </a:p>
+          <a:p>
+            <a:pPr algn="l"/>
+            <a:r>
+              <a:rPr lang="ru-RU" sz="1500" b="0">
                 <a:solidFill>
                   <a:srgbClr val="18212B"/>
                 </a:solidFill>
@@ -2353,20 +2353,20 @@
           <a:p>
             <a:pPr algn="l"/>
             <a:r>
-              <a:rPr lang="ru-RU" sz="1500" b="1">
-                <a:solidFill>
-                  <a:srgbClr val="18212B"/>
-                </a:solidFill>
-                <a:latin typeface="Aptos"/>
-                <a:cs typeface="Aptos"/>
-              </a:rPr>
-              <a:t>• Multi-instance с Redis backplane — проверка решения</a:t>
-            </a:r>
-          </a:p>
-          <a:p>
-            <a:pPr algn="l"/>
-            <a:r>
-              <a:rPr lang="ru-RU" sz="1500" b="1">
+              <a:rPr lang="ru-RU" sz="1500" b="0">
+                <a:solidFill>
+                  <a:srgbClr val="18212B"/>
+                </a:solidFill>
+                <a:latin typeface="Aptos"/>
+                <a:cs typeface="Aptos"/>
+              </a:rPr>
+              <a:t>• С межузловым каналом — проверка решения</a:t>
+            </a:r>
+          </a:p>
+          <a:p>
+            <a:pPr algn="l"/>
+            <a:r>
+              <a:rPr lang="ru-RU" sz="1500" b="0">
                 <a:solidFill>
                   <a:srgbClr val="18212B"/>
                 </a:solidFill>
@@ -2379,14 +2379,14 @@
           <a:p>
             <a:pPr algn="l"/>
             <a:r>
-              <a:rPr lang="ru-RU" sz="1500" b="1">
-                <a:solidFill>
-                  <a:srgbClr val="18212B"/>
-                </a:solidFill>
-                <a:latin typeface="Aptos"/>
-                <a:cs typeface="Aptos"/>
-              </a:rPr>
-              <a:t>Один и тот же код, один и тот же сценарий; отличие — значение REDIS_CONNECTION_STRING.</a:t>
+              <a:rPr lang="ru-RU" sz="1500" b="0">
+                <a:solidFill>
+                  <a:srgbClr val="18212B"/>
+                </a:solidFill>
+                <a:latin typeface="Aptos"/>
+                <a:cs typeface="Aptos"/>
+              </a:rPr>
+              <a:t>Один и тот же код, один и тот же сценарий; отличие — наличие Redis backplane.</a:t>
             </a:r>
           </a:p>
         </p:txBody>
@@ -2453,7 +2453,7 @@
                 <a:latin typeface="Aptos"/>
                 <a:cs typeface="Aptos"/>
               </a:rPr>
-              <a:t>• Одиночная cross-node доставка</a:t>
+              <a:t>• Одиночная доставка между узлами</a:t>
             </a:r>
           </a:p>
           <a:p>
@@ -2479,7 +2479,7 @@
                 <a:latin typeface="Aptos"/>
                 <a:cs typeface="Aptos"/>
               </a:rPr>
-              <a:t>• Серия из 5 итераций (THESIS_ITERATIONS)</a:t>
+              <a:t>• Серия из пяти итераций</a:t>
             </a:r>
           </a:p>
           <a:p>
@@ -2505,7 +2505,7 @@
                 <a:latin typeface="Aptos"/>
                 <a:cs typeface="Aptos"/>
               </a:rPr>
-              <a:t>• Rejoin после разрыва соединения</a:t>
+              <a:t>• Восстановление подписки после разрыва</a:t>
             </a:r>
           </a:p>
           <a:p>
@@ -2531,7 +2531,7 @@
                 <a:latin typeface="Aptos"/>
                 <a:cs typeface="Aptos"/>
               </a:rPr>
-              <a:t>• Failover после остановки узла</a:t>
+              <a:t>• Переключение на другой узел после отказа</a:t>
             </a:r>
           </a:p>
         </p:txBody>
@@ -3068,7 +3068,7 @@
                 <a:latin typeface="Aptos"/>
                 <a:cs typeface="Aptos"/>
               </a:rPr>
-              <a:t>Повторяемость, повторное вступление в группу и восстановление после отказа узла</a:t>
+              <a:t>Повторяемость, восстановление подписки и переключение после отказа узла</a:t>
             </a:r>
           </a:p>
         </p:txBody>
@@ -3082,164 +3082,6 @@
         <p:spPr>
           <a:xfrm>
             <a:off x="685800" y="1600200"/>
-            <a:ext cx="3657600" cy="4114800"/>
-          </a:xfrm>
-          <a:prstGeom prst="roundRect">
-            <a:avLst/>
-          </a:prstGeom>
-          <a:solidFill>
-            <a:srgbClr val="E8F3F1"/>
-          </a:solidFill>
-          <a:ln w="12700">
-            <a:solidFill>
-              <a:srgbClr val="0B6E69"/>
-            </a:solidFill>
-          </a:ln>
-        </p:spPr>
-        <p:txBody>
-          <a:bodyPr wrap="square" lIns="177800" tIns="177800" rIns="177800" bIns="177800"/>
-          <a:lstStyle/>
-          <a:p>
-            <a:pPr algn="l"/>
-            <a:r>
-              <a:rPr lang="ru-RU" sz="1500" b="0">
-                <a:solidFill>
-                  <a:srgbClr val="18212B"/>
-                </a:solidFill>
-                <a:latin typeface="Aptos"/>
-                <a:cs typeface="Aptos"/>
-              </a:rPr>
-              <a:t>Серия 5 итераций</a:t>
-            </a:r>
-          </a:p>
-          <a:p>
-            <a:pPr algn="l"/>
-            <a:r>
-              <a:rPr lang="ru-RU" sz="1500" b="0">
-                <a:solidFill>
-                  <a:srgbClr val="18212B"/>
-                </a:solidFill>
-                <a:latin typeface="Aptos"/>
-                <a:cs typeface="Aptos"/>
-              </a:rPr>
-              <a:t/>
-            </a:r>
-          </a:p>
-          <a:p>
-            <a:pPr algn="l"/>
-            <a:r>
-              <a:rPr lang="ru-RU" sz="1500" b="0">
-                <a:solidFill>
-                  <a:srgbClr val="18212B"/>
-                </a:solidFill>
-                <a:latin typeface="Aptos"/>
-                <a:cs typeface="Aptos"/>
-              </a:rPr>
-              <a:t>successful 5 / 5</a:t>
-            </a:r>
-          </a:p>
-          <a:p>
-            <a:pPr algn="l"/>
-            <a:r>
-              <a:rPr lang="ru-RU" sz="1500" b="0">
-                <a:solidFill>
-                  <a:srgbClr val="18212B"/>
-                </a:solidFill>
-                <a:latin typeface="Aptos"/>
-                <a:cs typeface="Aptos"/>
-              </a:rPr>
-              <a:t/>
-            </a:r>
-          </a:p>
-          <a:p>
-            <a:pPr algn="l"/>
-            <a:r>
-              <a:rPr lang="ru-RU" sz="1500" b="0">
-                <a:solidFill>
-                  <a:srgbClr val="18212B"/>
-                </a:solidFill>
-                <a:latin typeface="Aptos"/>
-                <a:cs typeface="Aptos"/>
-              </a:rPr>
-              <a:t>min 5,5 мс</a:t>
-            </a:r>
-          </a:p>
-          <a:p>
-            <a:pPr algn="l"/>
-            <a:r>
-              <a:rPr lang="ru-RU" sz="1500" b="0">
-                <a:solidFill>
-                  <a:srgbClr val="18212B"/>
-                </a:solidFill>
-                <a:latin typeface="Aptos"/>
-                <a:cs typeface="Aptos"/>
-              </a:rPr>
-              <a:t>avg 8,4 мс</a:t>
-            </a:r>
-          </a:p>
-          <a:p>
-            <a:pPr algn="l"/>
-            <a:r>
-              <a:rPr lang="ru-RU" sz="1500" b="0">
-                <a:solidFill>
-                  <a:srgbClr val="18212B"/>
-                </a:solidFill>
-                <a:latin typeface="Aptos"/>
-                <a:cs typeface="Aptos"/>
-              </a:rPr>
-              <a:t>p50 9,1 мс</a:t>
-            </a:r>
-          </a:p>
-          <a:p>
-            <a:pPr algn="l"/>
-            <a:r>
-              <a:rPr lang="ru-RU" sz="1500" b="0">
-                <a:solidFill>
-                  <a:srgbClr val="18212B"/>
-                </a:solidFill>
-                <a:latin typeface="Aptos"/>
-                <a:cs typeface="Aptos"/>
-              </a:rPr>
-              <a:t>p95 11,6 мс</a:t>
-            </a:r>
-          </a:p>
-          <a:p>
-            <a:pPr algn="l"/>
-            <a:r>
-              <a:rPr lang="ru-RU" sz="1500" b="0">
-                <a:solidFill>
-                  <a:srgbClr val="18212B"/>
-                </a:solidFill>
-                <a:latin typeface="Aptos"/>
-                <a:cs typeface="Aptos"/>
-              </a:rPr>
-              <a:t/>
-            </a:r>
-          </a:p>
-          <a:p>
-            <a:pPr algn="l"/>
-            <a:r>
-              <a:rPr lang="ru-RU" sz="1500" b="0">
-                <a:solidFill>
-                  <a:srgbClr val="18212B"/>
-                </a:solidFill>
-                <a:latin typeface="Aptos"/>
-                <a:cs typeface="Aptos"/>
-              </a:rPr>
-              <a:t>Подтверждена повторяемость доставки.</a:t>
-            </a:r>
-          </a:p>
-        </p:txBody>
-      </p:sp>
-      <p:sp>
-        <p:nvSpPr>
-          <p:cNvPr id="21" name="Shape 21"/>
-          <p:cNvSpPr txBox="1"/>
-          <p:nvPr/>
-        </p:nvSpPr>
-        <p:spPr>
-          <a:xfrm>
-            <a:off x="4434840" y="1600200"/>
             <a:ext cx="3657600" cy="4114800"/>
           </a:xfrm>
           <a:prstGeom prst="roundRect">
@@ -3267,7 +3109,7 @@
                 <a:latin typeface="Aptos"/>
                 <a:cs typeface="Aptos"/>
               </a:rPr>
-              <a:t>Rejoin после разрыва</a:t>
+              <a:t>Серия из 5 итераций</a:t>
             </a:r>
           </a:p>
           <a:p>
@@ -3293,20 +3135,7 @@
                 <a:latin typeface="Aptos"/>
                 <a:cs typeface="Aptos"/>
               </a:rPr>
-              <a:t>Новый connectionId</a:t>
-            </a:r>
-          </a:p>
-          <a:p>
-            <a:pPr algn="l"/>
-            <a:r>
-              <a:rPr lang="ru-RU" sz="1500" b="0">
-                <a:solidFill>
-                  <a:srgbClr val="18212B"/>
-                </a:solidFill>
-                <a:latin typeface="Aptos"/>
-                <a:cs typeface="Aptos"/>
-              </a:rPr>
-              <a:t>повторный JoinReportGroupAsync</a:t>
+              <a:t>Успешно: 5 из 5</a:t>
             </a:r>
           </a:p>
           <a:p>
@@ -3332,20 +3161,46 @@
                 <a:latin typeface="Aptos"/>
                 <a:cs typeface="Aptos"/>
               </a:rPr>
-              <a:t>rejoin 12,9 мс</a:t>
-            </a:r>
-          </a:p>
-          <a:p>
-            <a:pPr algn="l"/>
-            <a:r>
-              <a:rPr lang="ru-RU" sz="1500" b="0">
-                <a:solidFill>
-                  <a:srgbClr val="18212B"/>
-                </a:solidFill>
-                <a:latin typeface="Aptos"/>
-                <a:cs typeface="Aptos"/>
-              </a:rPr>
-              <a:t>delivery 6,6 мс</a:t>
+              <a:t>min 5,5 мс</a:t>
+            </a:r>
+          </a:p>
+          <a:p>
+            <a:pPr algn="l"/>
+            <a:r>
+              <a:rPr lang="ru-RU" sz="1500" b="0">
+                <a:solidFill>
+                  <a:srgbClr val="18212B"/>
+                </a:solidFill>
+                <a:latin typeface="Aptos"/>
+                <a:cs typeface="Aptos"/>
+              </a:rPr>
+              <a:t>avg 8,4 мс</a:t>
+            </a:r>
+          </a:p>
+          <a:p>
+            <a:pPr algn="l"/>
+            <a:r>
+              <a:rPr lang="ru-RU" sz="1500" b="0">
+                <a:solidFill>
+                  <a:srgbClr val="18212B"/>
+                </a:solidFill>
+                <a:latin typeface="Aptos"/>
+                <a:cs typeface="Aptos"/>
+              </a:rPr>
+              <a:t>p50 9,1 мс</a:t>
+            </a:r>
+          </a:p>
+          <a:p>
+            <a:pPr algn="l"/>
+            <a:r>
+              <a:rPr lang="ru-RU" sz="1500" b="0">
+                <a:solidFill>
+                  <a:srgbClr val="18212B"/>
+                </a:solidFill>
+                <a:latin typeface="Aptos"/>
+                <a:cs typeface="Aptos"/>
+              </a:rPr>
+              <a:t>p95 11,6 мс</a:t>
             </a:r>
           </a:p>
           <a:p>
@@ -3371,20 +3226,20 @@
                 <a:latin typeface="Aptos"/>
                 <a:cs typeface="Aptos"/>
               </a:rPr>
-              <a:t>Подтверждена повторная подписка.</a:t>
-            </a:r>
-          </a:p>
-        </p:txBody>
-      </p:sp>
-      <p:sp>
-        <p:nvSpPr>
-          <p:cNvPr id="22" name="Shape 22"/>
-          <p:cNvSpPr txBox="1"/>
-          <p:nvPr/>
-        </p:nvSpPr>
-        <p:spPr>
-          <a:xfrm>
-            <a:off x="8183880" y="1600200"/>
+              <a:t>Подтверждена повторяемость доставки.</a:t>
+            </a:r>
+          </a:p>
+        </p:txBody>
+      </p:sp>
+      <p:sp>
+        <p:nvSpPr>
+          <p:cNvPr id="21" name="Shape 21"/>
+          <p:cNvSpPr txBox="1"/>
+          <p:nvPr/>
+        </p:nvSpPr>
+        <p:spPr>
+          <a:xfrm>
+            <a:off x="4434840" y="1600200"/>
             <a:ext cx="3657600" cy="4114800"/>
           </a:xfrm>
           <a:prstGeom prst="roundRect">
@@ -3412,7 +3267,7 @@
                 <a:latin typeface="Aptos"/>
                 <a:cs typeface="Aptos"/>
               </a:rPr>
-              <a:t>Failover узла</a:t>
+              <a:t>Восстановление подписки</a:t>
             </a:r>
           </a:p>
           <a:p>
@@ -3438,20 +3293,7 @@
                 <a:latin typeface="Aptos"/>
                 <a:cs typeface="Aptos"/>
               </a:rPr>
-              <a:t>Контейнер app-api-2 остановлен</a:t>
-            </a:r>
-          </a:p>
-          <a:p>
-            <a:pPr algn="l"/>
-            <a:r>
-              <a:rPr lang="ru-RU" sz="1500" b="0">
-                <a:solidFill>
-                  <a:srgbClr val="18212B"/>
-                </a:solidFill>
-                <a:latin typeface="Aptos"/>
-                <a:cs typeface="Aptos"/>
-              </a:rPr>
-              <a:t>клиент переподключился через nginx к app-api-1</a:t>
+              <a:t>После разрыва клиент создаёт новое соединение и снова вступает в группу отчёта.</a:t>
             </a:r>
           </a:p>
           <a:p>
@@ -3477,20 +3319,20 @@
                 <a:latin typeface="Aptos"/>
                 <a:cs typeface="Aptos"/>
               </a:rPr>
-              <a:t>reconnect 240,3 мс</a:t>
-            </a:r>
-          </a:p>
-          <a:p>
-            <a:pPr algn="l"/>
-            <a:r>
-              <a:rPr lang="ru-RU" sz="1500" b="0">
-                <a:solidFill>
-                  <a:srgbClr val="18212B"/>
-                </a:solidFill>
-                <a:latin typeface="Aptos"/>
-                <a:cs typeface="Aptos"/>
-              </a:rPr>
-              <a:t>delivery 7,3 мс</a:t>
+              <a:t>переподключение 12,9 мс</a:t>
+            </a:r>
+          </a:p>
+          <a:p>
+            <a:pPr algn="l"/>
+            <a:r>
+              <a:rPr lang="ru-RU" sz="1500" b="0">
+                <a:solidFill>
+                  <a:srgbClr val="18212B"/>
+                </a:solidFill>
+                <a:latin typeface="Aptos"/>
+                <a:cs typeface="Aptos"/>
+              </a:rPr>
+              <a:t>доставка 6,6 мс</a:t>
             </a:r>
           </a:p>
           <a:p>
@@ -3516,7 +3358,139 @@
                 <a:latin typeface="Aptos"/>
                 <a:cs typeface="Aptos"/>
               </a:rPr>
-              <a:t>Подтверждено восстановление после отказа узла.</a:t>
+              <a:t>Подтверждена повторная подписка.</a:t>
+            </a:r>
+          </a:p>
+        </p:txBody>
+      </p:sp>
+      <p:sp>
+        <p:nvSpPr>
+          <p:cNvPr id="22" name="Shape 22"/>
+          <p:cNvSpPr txBox="1"/>
+          <p:nvPr/>
+        </p:nvSpPr>
+        <p:spPr>
+          <a:xfrm>
+            <a:off x="8183880" y="1600200"/>
+            <a:ext cx="3657600" cy="4114800"/>
+          </a:xfrm>
+          <a:prstGeom prst="roundRect">
+            <a:avLst/>
+          </a:prstGeom>
+          <a:solidFill>
+            <a:srgbClr val="FFFFFF"/>
+          </a:solidFill>
+          <a:ln w="12700">
+            <a:solidFill>
+              <a:srgbClr val="D7D2C7"/>
+            </a:solidFill>
+          </a:ln>
+        </p:spPr>
+        <p:txBody>
+          <a:bodyPr wrap="square" lIns="177800" tIns="177800" rIns="177800" bIns="177800"/>
+          <a:lstStyle/>
+          <a:p>
+            <a:pPr algn="l"/>
+            <a:r>
+              <a:rPr lang="ru-RU" sz="1500" b="0">
+                <a:solidFill>
+                  <a:srgbClr val="18212B"/>
+                </a:solidFill>
+                <a:latin typeface="Aptos"/>
+                <a:cs typeface="Aptos"/>
+              </a:rPr>
+              <a:t>Переключение после отказа узла</a:t>
+            </a:r>
+          </a:p>
+          <a:p>
+            <a:pPr algn="l"/>
+            <a:r>
+              <a:rPr lang="ru-RU" sz="1500" b="0">
+                <a:solidFill>
+                  <a:srgbClr val="18212B"/>
+                </a:solidFill>
+                <a:latin typeface="Aptos"/>
+                <a:cs typeface="Aptos"/>
+              </a:rPr>
+              <a:t/>
+            </a:r>
+          </a:p>
+          <a:p>
+            <a:pPr algn="l"/>
+            <a:r>
+              <a:rPr lang="ru-RU" sz="1500" b="0">
+                <a:solidFill>
+                  <a:srgbClr val="18212B"/>
+                </a:solidFill>
+                <a:latin typeface="Aptos"/>
+                <a:cs typeface="Aptos"/>
+              </a:rPr>
+              <a:t>Один backend остановлен; nginx переключает клиента на другой экземпляр.</a:t>
+            </a:r>
+          </a:p>
+          <a:p>
+            <a:pPr algn="l"/>
+            <a:r>
+              <a:rPr lang="ru-RU" sz="1500" b="0">
+                <a:solidFill>
+                  <a:srgbClr val="18212B"/>
+                </a:solidFill>
+                <a:latin typeface="Aptos"/>
+                <a:cs typeface="Aptos"/>
+              </a:rPr>
+              <a:t/>
+            </a:r>
+          </a:p>
+          <a:p>
+            <a:pPr algn="l"/>
+            <a:r>
+              <a:rPr lang="ru-RU" sz="1500" b="0">
+                <a:solidFill>
+                  <a:srgbClr val="18212B"/>
+                </a:solidFill>
+                <a:latin typeface="Aptos"/>
+                <a:cs typeface="Aptos"/>
+              </a:rPr>
+              <a:t>переподключение 240,3 мс</a:t>
+            </a:r>
+          </a:p>
+          <a:p>
+            <a:pPr algn="l"/>
+            <a:r>
+              <a:rPr lang="ru-RU" sz="1500" b="0">
+                <a:solidFill>
+                  <a:srgbClr val="18212B"/>
+                </a:solidFill>
+                <a:latin typeface="Aptos"/>
+                <a:cs typeface="Aptos"/>
+              </a:rPr>
+              <a:t>доставка 7,3 мс</a:t>
+            </a:r>
+          </a:p>
+          <a:p>
+            <a:pPr algn="l"/>
+            <a:r>
+              <a:rPr lang="ru-RU" sz="1500" b="0">
+                <a:solidFill>
+                  <a:srgbClr val="18212B"/>
+                </a:solidFill>
+                <a:latin typeface="Aptos"/>
+                <a:cs typeface="Aptos"/>
+              </a:rPr>
+              <a:t/>
+            </a:r>
+          </a:p>
+          <a:p>
+            <a:pPr algn="l"/>
+            <a:r>
+              <a:rPr lang="ru-RU" sz="1500" b="0">
+                <a:solidFill>
+                  <a:srgbClr val="18212B"/>
+                </a:solidFill>
+                <a:latin typeface="Aptos"/>
+                <a:cs typeface="Aptos"/>
+              </a:rPr>
+              <a:t>Подтверждено восстановление после отказа.</a:t>
             </a:r>
           </a:p>
         </p:txBody>
@@ -3637,7 +3611,7 @@
         <p:spPr>
           <a:xfrm>
             <a:off x="685800" y="1554480"/>
-            <a:ext cx="10835640" cy="1371600"/>
+            <a:ext cx="10835640" cy="1280160"/>
           </a:xfrm>
           <a:prstGeom prst="roundRect">
             <a:avLst/>
@@ -3657,7 +3631,7 @@
           <a:p>
             <a:pPr algn="ctr"/>
             <a:r>
-              <a:rPr lang="ru-RU" sz="1800" b="1">
+              <a:rPr lang="ru-RU" sz="1700" b="1">
                 <a:solidFill>
                   <a:srgbClr val="18212B"/>
                 </a:solidFill>
@@ -3677,8 +3651,49 @@
         </p:nvSpPr>
         <p:spPr>
           <a:xfrm>
-            <a:off x="685800" y="3108960"/>
-            <a:ext cx="3520440" cy="2606040"/>
+            <a:off x="685800" y="2971800"/>
+            <a:ext cx="10835640" cy="1417320"/>
+          </a:xfrm>
+          <a:prstGeom prst="roundRect">
+            <a:avLst/>
+          </a:prstGeom>
+          <a:solidFill>
+            <a:srgbClr val="FFF3D8"/>
+          </a:solidFill>
+          <a:ln w="12700">
+            <a:solidFill>
+              <a:srgbClr val="C76F2E"/>
+            </a:solidFill>
+          </a:ln>
+        </p:spPr>
+        <p:txBody>
+          <a:bodyPr wrap="square" lIns="177800" tIns="177800" rIns="177800" bIns="177800"/>
+          <a:lstStyle/>
+          <a:p>
+            <a:pPr algn="ctr"/>
+            <a:r>
+              <a:rPr lang="ru-RU" sz="1500" b="1">
+                <a:solidFill>
+                  <a:srgbClr val="18212B"/>
+                </a:solidFill>
+                <a:latin typeface="Aptos"/>
+                <a:cs typeface="Aptos"/>
+              </a:rPr>
+              <a:t>Дополнительный эффект — повышение отказоустойчивости: при отказе одного узла клиенты продолжают получать события через другой экземпляр backend, тогда как single-node архитектура такой возможности не предоставляет.</a:t>
+            </a:r>
+          </a:p>
+        </p:txBody>
+      </p:sp>
+      <p:sp>
+        <p:nvSpPr>
+          <p:cNvPr id="22" name="Shape 22"/>
+          <p:cNvSpPr txBox="1"/>
+          <p:nvPr/>
+        </p:nvSpPr>
+        <p:spPr>
+          <a:xfrm>
+            <a:off x="685800" y="4572000"/>
+            <a:ext cx="3520440" cy="1691640"/>
           </a:xfrm>
           <a:prstGeom prst="roundRect">
             <a:avLst/>
@@ -3698,7 +3713,7 @@
           <a:p>
             <a:pPr algn="l"/>
             <a:r>
-              <a:rPr lang="ru-RU" sz="1400" b="1">
+              <a:rPr lang="ru-RU" sz="1300" b="1">
                 <a:solidFill>
                   <a:srgbClr val="18212B"/>
                 </a:solidFill>
@@ -3711,7 +3726,7 @@
           <a:p>
             <a:pPr algn="l"/>
             <a:r>
-              <a:rPr lang="ru-RU" sz="1400" b="1">
+              <a:rPr lang="ru-RU" sz="1300" b="1">
                 <a:solidFill>
                   <a:srgbClr val="18212B"/>
                 </a:solidFill>
@@ -3724,7 +3739,7 @@
           <a:p>
             <a:pPr algn="l"/>
             <a:r>
-              <a:rPr lang="ru-RU" sz="1400" b="1">
+              <a:rPr lang="ru-RU" sz="1300" b="1">
                 <a:solidFill>
                   <a:srgbClr val="18212B"/>
                 </a:solidFill>
@@ -3738,14 +3753,14 @@
       </p:sp>
       <p:sp>
         <p:nvSpPr>
-          <p:cNvPr id="22" name="Shape 22"/>
-          <p:cNvSpPr txBox="1"/>
-          <p:nvPr/>
-        </p:nvSpPr>
-        <p:spPr>
-          <a:xfrm>
-            <a:off x="4343400" y="3108960"/>
-            <a:ext cx="3520440" cy="2606040"/>
+          <p:cNvPr id="23" name="Shape 23"/>
+          <p:cNvSpPr txBox="1"/>
+          <p:nvPr/>
+        </p:nvSpPr>
+        <p:spPr>
+          <a:xfrm>
+            <a:off x="4343400" y="4572000"/>
+            <a:ext cx="3520440" cy="1691640"/>
           </a:xfrm>
           <a:prstGeom prst="roundRect">
             <a:avLst/>
@@ -3765,7 +3780,7 @@
           <a:p>
             <a:pPr algn="l"/>
             <a:r>
-              <a:rPr lang="ru-RU" sz="1400" b="1">
+              <a:rPr lang="ru-RU" sz="1300" b="1">
                 <a:solidFill>
                   <a:srgbClr val="18212B"/>
                 </a:solidFill>
@@ -3778,7 +3793,7 @@
           <a:p>
             <a:pPr algn="l"/>
             <a:r>
-              <a:rPr lang="ru-RU" sz="1400" b="1">
+              <a:rPr lang="ru-RU" sz="1300" b="1">
                 <a:solidFill>
                   <a:srgbClr val="18212B"/>
                 </a:solidFill>
@@ -3791,28 +3806,28 @@
           <a:p>
             <a:pPr algn="l"/>
             <a:r>
-              <a:rPr lang="ru-RU" sz="1400" b="1">
-                <a:solidFill>
-                  <a:srgbClr val="18212B"/>
-                </a:solidFill>
-                <a:latin typeface="Aptos"/>
-                <a:cs typeface="Aptos"/>
-              </a:rPr>
-              <a:t>SignalR + Redis backplane + nginx + два app-api; общий код, конфигурация через переменную окружения.</a:t>
-            </a:r>
-          </a:p>
-        </p:txBody>
-      </p:sp>
-      <p:sp>
-        <p:nvSpPr>
-          <p:cNvPr id="23" name="Shape 23"/>
-          <p:cNvSpPr txBox="1"/>
-          <p:nvPr/>
-        </p:nvSpPr>
-        <p:spPr>
-          <a:xfrm>
-            <a:off x="8001000" y="3108960"/>
-            <a:ext cx="3520440" cy="2606040"/>
+              <a:rPr lang="ru-RU" sz="1300" b="1">
+                <a:solidFill>
+                  <a:srgbClr val="18212B"/>
+                </a:solidFill>
+                <a:latin typeface="Aptos"/>
+                <a:cs typeface="Aptos"/>
+              </a:rPr>
+              <a:t>Несколько экземпляров backend за nginx + Redis backplane; общий код, переключение режима — переменной окружения.</a:t>
+            </a:r>
+          </a:p>
+        </p:txBody>
+      </p:sp>
+      <p:sp>
+        <p:nvSpPr>
+          <p:cNvPr id="24" name="Shape 24"/>
+          <p:cNvSpPr txBox="1"/>
+          <p:nvPr/>
+        </p:nvSpPr>
+        <p:spPr>
+          <a:xfrm>
+            <a:off x="8001000" y="4572000"/>
+            <a:ext cx="3520440" cy="1691640"/>
           </a:xfrm>
           <a:prstGeom prst="roundRect">
             <a:avLst/>
@@ -3832,7 +3847,7 @@
           <a:p>
             <a:pPr algn="l"/>
             <a:r>
-              <a:rPr lang="ru-RU" sz="1400" b="1">
+              <a:rPr lang="ru-RU" sz="1300" b="1">
                 <a:solidFill>
                   <a:srgbClr val="18212B"/>
                 </a:solidFill>
@@ -3845,7 +3860,7 @@
           <a:p>
             <a:pPr algn="l"/>
             <a:r>
-              <a:rPr lang="ru-RU" sz="1400" b="1">
+              <a:rPr lang="ru-RU" sz="1300" b="1">
                 <a:solidFill>
                   <a:srgbClr val="18212B"/>
                 </a:solidFill>
@@ -3858,14 +3873,14 @@
           <a:p>
             <a:pPr algn="l"/>
             <a:r>
-              <a:rPr lang="ru-RU" sz="1400" b="1">
-                <a:solidFill>
-                  <a:srgbClr val="18212B"/>
-                </a:solidFill>
-                <a:latin typeface="Aptos"/>
-                <a:cs typeface="Aptos"/>
-              </a:rPr>
-              <a:t>Delivery (без / с) · серия 5 / 5 · rejoin · failover — воспроизводимый Docker Compose стенд.</a:t>
+              <a:rPr lang="ru-RU" sz="1300" b="1">
+                <a:solidFill>
+                  <a:srgbClr val="18212B"/>
+                </a:solidFill>
+                <a:latin typeface="Aptos"/>
+                <a:cs typeface="Aptos"/>
+              </a:rPr>
+              <a:t>Доставка (без / с) · серия · восстановление подписки · переключение после отказа.</a:t>
             </a:r>
           </a:p>
         </p:txBody>

</xml_diff>